<commit_message>
Fix step limits, trim eco_loop.json, and cleanup for final submission
</commit_message>
<xml_diff>
--- a/IDEA_Presentation_FormatQ1.pptx
+++ b/IDEA_Presentation_FormatQ1.pptx
@@ -5,16 +5,15 @@
     <p:sldMasterId id="2147483648" r:id="rId1"/>
   </p:sldMasterIdLst>
   <p:notesMasterIdLst>
-    <p:notesMasterId r:id="rId9"/>
+    <p:notesMasterId r:id="rId8"/>
   </p:notesMasterIdLst>
   <p:sldIdLst>
-    <p:sldId id="297" r:id="rId2"/>
-    <p:sldId id="298" r:id="rId3"/>
-    <p:sldId id="281" r:id="rId4"/>
-    <p:sldId id="290" r:id="rId5"/>
-    <p:sldId id="293" r:id="rId6"/>
-    <p:sldId id="299" r:id="rId7"/>
-    <p:sldId id="296" r:id="rId8"/>
+    <p:sldId id="298" r:id="rId2"/>
+    <p:sldId id="281" r:id="rId3"/>
+    <p:sldId id="290" r:id="rId4"/>
+    <p:sldId id="293" r:id="rId5"/>
+    <p:sldId id="299" r:id="rId6"/>
+    <p:sldId id="296" r:id="rId7"/>
   </p:sldIdLst>
   <p:sldSz cx="12192000" cy="6858000"/>
   <p:notesSz cx="6858000" cy="9144000"/>
@@ -262,7 +261,7 @@
             <a:fld id="{C4D5ADD5-2BBC-4A94-8F86-D9013941F742}" type="datetimeFigureOut">
               <a:rPr lang="en-US"/>
               <a:pPr/>
-              <a:t>7/24/2026</a:t>
+              <a:t>7/26/2026</a:t>
             </a:fld>
             <a:endParaRPr lang="en-US"/>
           </a:p>
@@ -599,6 +598,244 @@
       </p:grpSpPr>
       <p:sp>
         <p:nvSpPr>
+          <p:cNvPr id="16385" name="Slide Image Placeholder 1"/>
+          <p:cNvSpPr>
+            <a:spLocks noGrp="1" noRot="1" noChangeAspect="1"/>
+          </p:cNvSpPr>
+          <p:nvPr>
+            <p:ph type="sldImg"/>
+          </p:nvPr>
+        </p:nvSpPr>
+        <p:spPr bwMode="auto">
+          <a:xfrm>
+            <a:off x="381000" y="685800"/>
+            <a:ext cx="6096000" cy="3429000"/>
+          </a:xfrm>
+          <a:noFill/>
+          <a:ln>
+            <a:solidFill>
+              <a:srgbClr val="000000"/>
+            </a:solidFill>
+            <a:miter lim="800000"/>
+            <a:headEnd/>
+            <a:tailEnd/>
+          </a:ln>
+        </p:spPr>
+      </p:sp>
+      <p:sp>
+        <p:nvSpPr>
+          <p:cNvPr id="16386" name="Notes Placeholder 2"/>
+          <p:cNvSpPr>
+            <a:spLocks noGrp="1"/>
+          </p:cNvSpPr>
+          <p:nvPr>
+            <p:ph type="body" idx="1"/>
+          </p:nvPr>
+        </p:nvSpPr>
+        <p:spPr bwMode="auto">
+          <a:noFill/>
+        </p:spPr>
+        <p:txBody>
+          <a:bodyPr wrap="square" numCol="1" anchor="t" anchorCtr="0" compatLnSpc="1">
+            <a:prstTxWarp prst="textNoShape">
+              <a:avLst/>
+            </a:prstTxWarp>
+          </a:bodyPr>
+          <a:lstStyle/>
+          <a:p>
+            <a:pPr eaLnBrk="1" hangingPunct="1">
+              <a:spcBef>
+                <a:spcPct val="0"/>
+              </a:spcBef>
+            </a:pPr>
+            <a:endParaRPr lang="en-US">
+              <a:ea typeface="ＭＳ Ｐゴシック" pitchFamily="1" charset="-128"/>
+            </a:endParaRPr>
+          </a:p>
+        </p:txBody>
+      </p:sp>
+      <p:sp>
+        <p:nvSpPr>
+          <p:cNvPr id="16387" name="Slide Number Placeholder 3"/>
+          <p:cNvSpPr>
+            <a:spLocks noGrp="1"/>
+          </p:cNvSpPr>
+          <p:nvPr>
+            <p:ph type="sldNum" sz="quarter" idx="5"/>
+          </p:nvPr>
+        </p:nvSpPr>
+        <p:spPr bwMode="auto">
+          <a:noFill/>
+          <a:ln>
+            <a:miter lim="800000"/>
+            <a:headEnd/>
+            <a:tailEnd/>
+          </a:ln>
+        </p:spPr>
+        <p:txBody>
+          <a:bodyPr/>
+          <a:lstStyle/>
+          <a:p>
+            <a:fld id="{65F62A7E-A2F8-438F-9CF8-47DE63F471B4}" type="slidenum">
+              <a:rPr lang="en-US"/>
+              <a:pPr/>
+              <a:t>2</a:t>
+            </a:fld>
+            <a:endParaRPr lang="en-US"/>
+          </a:p>
+        </p:txBody>
+      </p:sp>
+    </p:spTree>
+    <p:extLst>
+      <p:ext uri="{BB962C8B-B14F-4D97-AF65-F5344CB8AC3E}">
+        <p14:creationId xmlns:p14="http://schemas.microsoft.com/office/powerpoint/2010/main" val="2904073229"/>
+      </p:ext>
+    </p:extLst>
+  </p:cSld>
+  <p:clrMapOvr>
+    <a:masterClrMapping/>
+  </p:clrMapOvr>
+</p:notes>
+</file>
+
+<file path=ppt/notesSlides/notesSlide2.xml><?xml version="1.0" encoding="utf-8"?>
+<p:notes xmlns:a="http://schemas.openxmlformats.org/drawingml/2006/main" xmlns:r="http://schemas.openxmlformats.org/officeDocument/2006/relationships" xmlns:p="http://schemas.openxmlformats.org/presentationml/2006/main">
+  <p:cSld>
+    <p:spTree>
+      <p:nvGrpSpPr>
+        <p:cNvPr id="1" name=""/>
+        <p:cNvGrpSpPr/>
+        <p:nvPr/>
+      </p:nvGrpSpPr>
+      <p:grpSpPr>
+        <a:xfrm>
+          <a:off x="0" y="0"/>
+          <a:ext cx="0" cy="0"/>
+          <a:chOff x="0" y="0"/>
+          <a:chExt cx="0" cy="0"/>
+        </a:xfrm>
+      </p:grpSpPr>
+      <p:sp>
+        <p:nvSpPr>
+          <p:cNvPr id="18433" name="Slide Image Placeholder 1"/>
+          <p:cNvSpPr>
+            <a:spLocks noGrp="1" noRot="1" noChangeAspect="1"/>
+          </p:cNvSpPr>
+          <p:nvPr>
+            <p:ph type="sldImg"/>
+          </p:nvPr>
+        </p:nvSpPr>
+        <p:spPr bwMode="auto">
+          <a:xfrm>
+            <a:off x="381000" y="685800"/>
+            <a:ext cx="6096000" cy="3429000"/>
+          </a:xfrm>
+          <a:noFill/>
+          <a:ln>
+            <a:solidFill>
+              <a:srgbClr val="000000"/>
+            </a:solidFill>
+            <a:miter lim="800000"/>
+            <a:headEnd/>
+            <a:tailEnd/>
+          </a:ln>
+        </p:spPr>
+      </p:sp>
+      <p:sp>
+        <p:nvSpPr>
+          <p:cNvPr id="18434" name="Notes Placeholder 2"/>
+          <p:cNvSpPr>
+            <a:spLocks noGrp="1"/>
+          </p:cNvSpPr>
+          <p:nvPr>
+            <p:ph type="body" idx="1"/>
+          </p:nvPr>
+        </p:nvSpPr>
+        <p:spPr bwMode="auto">
+          <a:noFill/>
+        </p:spPr>
+        <p:txBody>
+          <a:bodyPr wrap="square" numCol="1" anchor="t" anchorCtr="0" compatLnSpc="1">
+            <a:prstTxWarp prst="textNoShape">
+              <a:avLst/>
+            </a:prstTxWarp>
+          </a:bodyPr>
+          <a:lstStyle/>
+          <a:p>
+            <a:pPr eaLnBrk="1" hangingPunct="1">
+              <a:spcBef>
+                <a:spcPct val="0"/>
+              </a:spcBef>
+            </a:pPr>
+            <a:endParaRPr lang="en-US">
+              <a:ea typeface="ＭＳ Ｐゴシック" pitchFamily="1" charset="-128"/>
+            </a:endParaRPr>
+          </a:p>
+        </p:txBody>
+      </p:sp>
+      <p:sp>
+        <p:nvSpPr>
+          <p:cNvPr id="18435" name="Slide Number Placeholder 3"/>
+          <p:cNvSpPr>
+            <a:spLocks noGrp="1"/>
+          </p:cNvSpPr>
+          <p:nvPr>
+            <p:ph type="sldNum" sz="quarter" idx="5"/>
+          </p:nvPr>
+        </p:nvSpPr>
+        <p:spPr bwMode="auto">
+          <a:noFill/>
+          <a:ln>
+            <a:miter lim="800000"/>
+            <a:headEnd/>
+            <a:tailEnd/>
+          </a:ln>
+        </p:spPr>
+        <p:txBody>
+          <a:bodyPr/>
+          <a:lstStyle/>
+          <a:p>
+            <a:fld id="{0CA7B74D-3791-4AC6-8451-F10DBCCCDD9A}" type="slidenum">
+              <a:rPr lang="en-US"/>
+              <a:pPr/>
+              <a:t>3</a:t>
+            </a:fld>
+            <a:endParaRPr lang="en-US"/>
+          </a:p>
+        </p:txBody>
+      </p:sp>
+    </p:spTree>
+    <p:extLst>
+      <p:ext uri="{BB962C8B-B14F-4D97-AF65-F5344CB8AC3E}">
+        <p14:creationId xmlns:p14="http://schemas.microsoft.com/office/powerpoint/2010/main" val="2335206292"/>
+      </p:ext>
+    </p:extLst>
+  </p:cSld>
+  <p:clrMapOvr>
+    <a:masterClrMapping/>
+  </p:clrMapOvr>
+</p:notes>
+</file>
+
+<file path=ppt/notesSlides/notesSlide3.xml><?xml version="1.0" encoding="utf-8"?>
+<p:notes xmlns:a="http://schemas.openxmlformats.org/drawingml/2006/main" xmlns:r="http://schemas.openxmlformats.org/officeDocument/2006/relationships" xmlns:p="http://schemas.openxmlformats.org/presentationml/2006/main">
+  <p:cSld>
+    <p:spTree>
+      <p:nvGrpSpPr>
+        <p:cNvPr id="1" name=""/>
+        <p:cNvGrpSpPr/>
+        <p:nvPr/>
+      </p:nvGrpSpPr>
+      <p:grpSpPr>
+        <a:xfrm>
+          <a:off x="0" y="0"/>
+          <a:ext cx="0" cy="0"/>
+          <a:chOff x="0" y="0"/>
+          <a:chExt cx="0" cy="0"/>
+        </a:xfrm>
+      </p:grpSpPr>
+      <p:sp>
+        <p:nvSpPr>
           <p:cNvPr id="18433" name="Slide Image Placeholder 1"/>
           <p:cNvSpPr>
             <a:spLocks noGrp="1" noRot="1" noChangeAspect="1"/>
@@ -726,7 +963,7 @@
                 <a:tabLst/>
                 <a:defRPr/>
               </a:pPr>
-              <a:t>1</a:t>
+              <a:t>4</a:t>
             </a:fld>
             <a:endParaRPr kumimoji="0" lang="en-US" sz="1200" b="0" i="0" u="none" strike="noStrike" kern="1200" cap="none" spc="0" normalizeH="0" baseline="0" noProof="0">
               <a:ln>
@@ -748,7 +985,7 @@
     </p:spTree>
     <p:extLst>
       <p:ext uri="{BB962C8B-B14F-4D97-AF65-F5344CB8AC3E}">
-        <p14:creationId xmlns:p14="http://schemas.microsoft.com/office/powerpoint/2010/main" val="3783576877"/>
+        <p14:creationId xmlns:p14="http://schemas.microsoft.com/office/powerpoint/2010/main" val="3773505461"/>
       </p:ext>
     </p:extLst>
   </p:cSld>
@@ -758,12 +995,18 @@
 </p:notes>
 </file>
 
-<file path=ppt/notesSlides/notesSlide2.xml><?xml version="1.0" encoding="utf-8"?>
+<file path=ppt/notesSlides/notesSlide4.xml><?xml version="1.0" encoding="utf-8"?>
 <p:notes xmlns:a="http://schemas.openxmlformats.org/drawingml/2006/main" xmlns:r="http://schemas.openxmlformats.org/officeDocument/2006/relationships" xmlns:p="http://schemas.openxmlformats.org/presentationml/2006/main">
   <p:cSld>
     <p:spTree>
       <p:nvGrpSpPr>
-        <p:cNvPr id="1" name=""/>
+        <p:cNvPr id="1" name="">
+          <a:extLst>
+            <a:ext uri="{FF2B5EF4-FFF2-40B4-BE49-F238E27FC236}">
+              <a16:creationId xmlns:a16="http://schemas.microsoft.com/office/drawing/2014/main" id="{9949F277-D966-5891-8E8E-FE1852E6B425}"/>
+            </a:ext>
+          </a:extLst>
+        </p:cNvPr>
         <p:cNvGrpSpPr/>
         <p:nvPr/>
       </p:nvGrpSpPr>
@@ -777,7 +1020,13 @@
       </p:grpSpPr>
       <p:sp>
         <p:nvSpPr>
-          <p:cNvPr id="16385" name="Slide Image Placeholder 1"/>
+          <p:cNvPr id="18433" name="Slide Image Placeholder 1">
+            <a:extLst>
+              <a:ext uri="{FF2B5EF4-FFF2-40B4-BE49-F238E27FC236}">
+                <a16:creationId xmlns:a16="http://schemas.microsoft.com/office/drawing/2014/main" id="{63166A99-EAE2-2E28-993F-D5871297B24D}"/>
+              </a:ext>
+            </a:extLst>
+          </p:cNvPr>
           <p:cNvSpPr>
             <a:spLocks noGrp="1" noRot="1" noChangeAspect="1"/>
           </p:cNvSpPr>
@@ -803,7 +1052,13 @@
       </p:sp>
       <p:sp>
         <p:nvSpPr>
-          <p:cNvPr id="16386" name="Notes Placeholder 2"/>
+          <p:cNvPr id="18434" name="Notes Placeholder 2">
+            <a:extLst>
+              <a:ext uri="{FF2B5EF4-FFF2-40B4-BE49-F238E27FC236}">
+                <a16:creationId xmlns:a16="http://schemas.microsoft.com/office/drawing/2014/main" id="{4ED88F3D-7791-59C8-716F-0AAD4C669A9A}"/>
+              </a:ext>
+            </a:extLst>
+          </p:cNvPr>
           <p:cNvSpPr>
             <a:spLocks noGrp="1"/>
           </p:cNvSpPr>
@@ -835,245 +1090,13 @@
       </p:sp>
       <p:sp>
         <p:nvSpPr>
-          <p:cNvPr id="16387" name="Slide Number Placeholder 3"/>
-          <p:cNvSpPr>
-            <a:spLocks noGrp="1"/>
-          </p:cNvSpPr>
-          <p:nvPr>
-            <p:ph type="sldNum" sz="quarter" idx="5"/>
-          </p:nvPr>
-        </p:nvSpPr>
-        <p:spPr bwMode="auto">
-          <a:noFill/>
-          <a:ln>
-            <a:miter lim="800000"/>
-            <a:headEnd/>
-            <a:tailEnd/>
-          </a:ln>
-        </p:spPr>
-        <p:txBody>
-          <a:bodyPr/>
-          <a:lstStyle/>
-          <a:p>
-            <a:fld id="{65F62A7E-A2F8-438F-9CF8-47DE63F471B4}" type="slidenum">
-              <a:rPr lang="en-US"/>
-              <a:pPr/>
-              <a:t>3</a:t>
-            </a:fld>
-            <a:endParaRPr lang="en-US"/>
-          </a:p>
-        </p:txBody>
-      </p:sp>
-    </p:spTree>
-    <p:extLst>
-      <p:ext uri="{BB962C8B-B14F-4D97-AF65-F5344CB8AC3E}">
-        <p14:creationId xmlns:p14="http://schemas.microsoft.com/office/powerpoint/2010/main" val="2904073229"/>
-      </p:ext>
-    </p:extLst>
-  </p:cSld>
-  <p:clrMapOvr>
-    <a:masterClrMapping/>
-  </p:clrMapOvr>
-</p:notes>
-</file>
-
-<file path=ppt/notesSlides/notesSlide3.xml><?xml version="1.0" encoding="utf-8"?>
-<p:notes xmlns:a="http://schemas.openxmlformats.org/drawingml/2006/main" xmlns:r="http://schemas.openxmlformats.org/officeDocument/2006/relationships" xmlns:p="http://schemas.openxmlformats.org/presentationml/2006/main">
-  <p:cSld>
-    <p:spTree>
-      <p:nvGrpSpPr>
-        <p:cNvPr id="1" name=""/>
-        <p:cNvGrpSpPr/>
-        <p:nvPr/>
-      </p:nvGrpSpPr>
-      <p:grpSpPr>
-        <a:xfrm>
-          <a:off x="0" y="0"/>
-          <a:ext cx="0" cy="0"/>
-          <a:chOff x="0" y="0"/>
-          <a:chExt cx="0" cy="0"/>
-        </a:xfrm>
-      </p:grpSpPr>
-      <p:sp>
-        <p:nvSpPr>
-          <p:cNvPr id="18433" name="Slide Image Placeholder 1"/>
-          <p:cNvSpPr>
-            <a:spLocks noGrp="1" noRot="1" noChangeAspect="1"/>
-          </p:cNvSpPr>
-          <p:nvPr>
-            <p:ph type="sldImg"/>
-          </p:nvPr>
-        </p:nvSpPr>
-        <p:spPr bwMode="auto">
-          <a:xfrm>
-            <a:off x="381000" y="685800"/>
-            <a:ext cx="6096000" cy="3429000"/>
-          </a:xfrm>
-          <a:noFill/>
-          <a:ln>
-            <a:solidFill>
-              <a:srgbClr val="000000"/>
-            </a:solidFill>
-            <a:miter lim="800000"/>
-            <a:headEnd/>
-            <a:tailEnd/>
-          </a:ln>
-        </p:spPr>
-      </p:sp>
-      <p:sp>
-        <p:nvSpPr>
-          <p:cNvPr id="18434" name="Notes Placeholder 2"/>
-          <p:cNvSpPr>
-            <a:spLocks noGrp="1"/>
-          </p:cNvSpPr>
-          <p:nvPr>
-            <p:ph type="body" idx="1"/>
-          </p:nvPr>
-        </p:nvSpPr>
-        <p:spPr bwMode="auto">
-          <a:noFill/>
-        </p:spPr>
-        <p:txBody>
-          <a:bodyPr wrap="square" numCol="1" anchor="t" anchorCtr="0" compatLnSpc="1">
-            <a:prstTxWarp prst="textNoShape">
-              <a:avLst/>
-            </a:prstTxWarp>
-          </a:bodyPr>
-          <a:lstStyle/>
-          <a:p>
-            <a:pPr eaLnBrk="1" hangingPunct="1">
-              <a:spcBef>
-                <a:spcPct val="0"/>
-              </a:spcBef>
-            </a:pPr>
-            <a:endParaRPr lang="en-US">
-              <a:ea typeface="ＭＳ Ｐゴシック" pitchFamily="1" charset="-128"/>
-            </a:endParaRPr>
-          </a:p>
-        </p:txBody>
-      </p:sp>
-      <p:sp>
-        <p:nvSpPr>
-          <p:cNvPr id="18435" name="Slide Number Placeholder 3"/>
-          <p:cNvSpPr>
-            <a:spLocks noGrp="1"/>
-          </p:cNvSpPr>
-          <p:nvPr>
-            <p:ph type="sldNum" sz="quarter" idx="5"/>
-          </p:nvPr>
-        </p:nvSpPr>
-        <p:spPr bwMode="auto">
-          <a:noFill/>
-          <a:ln>
-            <a:miter lim="800000"/>
-            <a:headEnd/>
-            <a:tailEnd/>
-          </a:ln>
-        </p:spPr>
-        <p:txBody>
-          <a:bodyPr/>
-          <a:lstStyle/>
-          <a:p>
-            <a:fld id="{0CA7B74D-3791-4AC6-8451-F10DBCCCDD9A}" type="slidenum">
-              <a:rPr lang="en-US"/>
-              <a:pPr/>
-              <a:t>4</a:t>
-            </a:fld>
-            <a:endParaRPr lang="en-US"/>
-          </a:p>
-        </p:txBody>
-      </p:sp>
-    </p:spTree>
-    <p:extLst>
-      <p:ext uri="{BB962C8B-B14F-4D97-AF65-F5344CB8AC3E}">
-        <p14:creationId xmlns:p14="http://schemas.microsoft.com/office/powerpoint/2010/main" val="2335206292"/>
-      </p:ext>
-    </p:extLst>
-  </p:cSld>
-  <p:clrMapOvr>
-    <a:masterClrMapping/>
-  </p:clrMapOvr>
-</p:notes>
-</file>
-
-<file path=ppt/notesSlides/notesSlide4.xml><?xml version="1.0" encoding="utf-8"?>
-<p:notes xmlns:a="http://schemas.openxmlformats.org/drawingml/2006/main" xmlns:r="http://schemas.openxmlformats.org/officeDocument/2006/relationships" xmlns:p="http://schemas.openxmlformats.org/presentationml/2006/main">
-  <p:cSld>
-    <p:spTree>
-      <p:nvGrpSpPr>
-        <p:cNvPr id="1" name=""/>
-        <p:cNvGrpSpPr/>
-        <p:nvPr/>
-      </p:nvGrpSpPr>
-      <p:grpSpPr>
-        <a:xfrm>
-          <a:off x="0" y="0"/>
-          <a:ext cx="0" cy="0"/>
-          <a:chOff x="0" y="0"/>
-          <a:chExt cx="0" cy="0"/>
-        </a:xfrm>
-      </p:grpSpPr>
-      <p:sp>
-        <p:nvSpPr>
-          <p:cNvPr id="18433" name="Slide Image Placeholder 1"/>
-          <p:cNvSpPr>
-            <a:spLocks noGrp="1" noRot="1" noChangeAspect="1"/>
-          </p:cNvSpPr>
-          <p:nvPr>
-            <p:ph type="sldImg"/>
-          </p:nvPr>
-        </p:nvSpPr>
-        <p:spPr bwMode="auto">
-          <a:xfrm>
-            <a:off x="381000" y="685800"/>
-            <a:ext cx="6096000" cy="3429000"/>
-          </a:xfrm>
-          <a:noFill/>
-          <a:ln>
-            <a:solidFill>
-              <a:srgbClr val="000000"/>
-            </a:solidFill>
-            <a:miter lim="800000"/>
-            <a:headEnd/>
-            <a:tailEnd/>
-          </a:ln>
-        </p:spPr>
-      </p:sp>
-      <p:sp>
-        <p:nvSpPr>
-          <p:cNvPr id="18434" name="Notes Placeholder 2"/>
-          <p:cNvSpPr>
-            <a:spLocks noGrp="1"/>
-          </p:cNvSpPr>
-          <p:nvPr>
-            <p:ph type="body" idx="1"/>
-          </p:nvPr>
-        </p:nvSpPr>
-        <p:spPr bwMode="auto">
-          <a:noFill/>
-        </p:spPr>
-        <p:txBody>
-          <a:bodyPr wrap="square" numCol="1" anchor="t" anchorCtr="0" compatLnSpc="1">
-            <a:prstTxWarp prst="textNoShape">
-              <a:avLst/>
-            </a:prstTxWarp>
-          </a:bodyPr>
-          <a:lstStyle/>
-          <a:p>
-            <a:pPr eaLnBrk="1" hangingPunct="1">
-              <a:spcBef>
-                <a:spcPct val="0"/>
-              </a:spcBef>
-            </a:pPr>
-            <a:endParaRPr lang="en-US">
-              <a:ea typeface="ＭＳ Ｐゴシック" pitchFamily="1" charset="-128"/>
-            </a:endParaRPr>
-          </a:p>
-        </p:txBody>
-      </p:sp>
-      <p:sp>
-        <p:nvSpPr>
-          <p:cNvPr id="18435" name="Slide Number Placeholder 3"/>
+          <p:cNvPr id="18435" name="Slide Number Placeholder 3">
+            <a:extLst>
+              <a:ext uri="{FF2B5EF4-FFF2-40B4-BE49-F238E27FC236}">
+                <a16:creationId xmlns:a16="http://schemas.microsoft.com/office/drawing/2014/main" id="{CC82298B-112C-33CB-5F98-D6F1C4A4C6DE}"/>
+              </a:ext>
+            </a:extLst>
+          </p:cNvPr>
           <p:cNvSpPr>
             <a:spLocks noGrp="1"/>
           </p:cNvSpPr>
@@ -1164,7 +1187,7 @@
     </p:spTree>
     <p:extLst>
       <p:ext uri="{BB962C8B-B14F-4D97-AF65-F5344CB8AC3E}">
-        <p14:creationId xmlns:p14="http://schemas.microsoft.com/office/powerpoint/2010/main" val="3773505461"/>
+        <p14:creationId xmlns:p14="http://schemas.microsoft.com/office/powerpoint/2010/main" val="4173051335"/>
       </p:ext>
     </p:extLst>
   </p:cSld>
@@ -1179,13 +1202,7 @@
   <p:cSld>
     <p:spTree>
       <p:nvGrpSpPr>
-        <p:cNvPr id="1" name="">
-          <a:extLst>
-            <a:ext uri="{FF2B5EF4-FFF2-40B4-BE49-F238E27FC236}">
-              <a16:creationId xmlns:a16="http://schemas.microsoft.com/office/drawing/2014/main" id="{9949F277-D966-5891-8E8E-FE1852E6B425}"/>
-            </a:ext>
-          </a:extLst>
-        </p:cNvPr>
+        <p:cNvPr id="1" name=""/>
         <p:cNvGrpSpPr/>
         <p:nvPr/>
       </p:nvGrpSpPr>
@@ -1199,13 +1216,7 @@
       </p:grpSpPr>
       <p:sp>
         <p:nvSpPr>
-          <p:cNvPr id="18433" name="Slide Image Placeholder 1">
-            <a:extLst>
-              <a:ext uri="{FF2B5EF4-FFF2-40B4-BE49-F238E27FC236}">
-                <a16:creationId xmlns:a16="http://schemas.microsoft.com/office/drawing/2014/main" id="{63166A99-EAE2-2E28-993F-D5871297B24D}"/>
-              </a:ext>
-            </a:extLst>
-          </p:cNvPr>
+          <p:cNvPr id="18433" name="Slide Image Placeholder 1"/>
           <p:cNvSpPr>
             <a:spLocks noGrp="1" noRot="1" noChangeAspect="1"/>
           </p:cNvSpPr>
@@ -1231,13 +1242,7 @@
       </p:sp>
       <p:sp>
         <p:nvSpPr>
-          <p:cNvPr id="18434" name="Notes Placeholder 2">
-            <a:extLst>
-              <a:ext uri="{FF2B5EF4-FFF2-40B4-BE49-F238E27FC236}">
-                <a16:creationId xmlns:a16="http://schemas.microsoft.com/office/drawing/2014/main" id="{4ED88F3D-7791-59C8-716F-0AAD4C669A9A}"/>
-              </a:ext>
-            </a:extLst>
-          </p:cNvPr>
+          <p:cNvPr id="18434" name="Notes Placeholder 2"/>
           <p:cNvSpPr>
             <a:spLocks noGrp="1"/>
           </p:cNvSpPr>
@@ -1269,13 +1274,7 @@
       </p:sp>
       <p:sp>
         <p:nvSpPr>
-          <p:cNvPr id="18435" name="Slide Number Placeholder 3">
-            <a:extLst>
-              <a:ext uri="{FF2B5EF4-FFF2-40B4-BE49-F238E27FC236}">
-                <a16:creationId xmlns:a16="http://schemas.microsoft.com/office/drawing/2014/main" id="{CC82298B-112C-33CB-5F98-D6F1C4A4C6DE}"/>
-              </a:ext>
-            </a:extLst>
-          </p:cNvPr>
+          <p:cNvPr id="18435" name="Slide Number Placeholder 3"/>
           <p:cNvSpPr>
             <a:spLocks noGrp="1"/>
           </p:cNvSpPr>
@@ -1345,184 +1344,6 @@
                 <a:defRPr/>
               </a:pPr>
               <a:t>6</a:t>
-            </a:fld>
-            <a:endParaRPr kumimoji="0" lang="en-US" sz="1200" b="0" i="0" u="none" strike="noStrike" kern="1200" cap="none" spc="0" normalizeH="0" baseline="0" noProof="0">
-              <a:ln>
-                <a:noFill/>
-              </a:ln>
-              <a:solidFill>
-                <a:prstClr val="black"/>
-              </a:solidFill>
-              <a:effectLst/>
-              <a:uLnTx/>
-              <a:uFillTx/>
-              <a:latin typeface="Calibri" pitchFamily="34" charset="0"/>
-              <a:ea typeface="ＭＳ Ｐゴシック" pitchFamily="1" charset="-128"/>
-              <a:cs typeface="+mn-cs"/>
-            </a:endParaRPr>
-          </a:p>
-        </p:txBody>
-      </p:sp>
-    </p:spTree>
-    <p:extLst>
-      <p:ext uri="{BB962C8B-B14F-4D97-AF65-F5344CB8AC3E}">
-        <p14:creationId xmlns:p14="http://schemas.microsoft.com/office/powerpoint/2010/main" val="4173051335"/>
-      </p:ext>
-    </p:extLst>
-  </p:cSld>
-  <p:clrMapOvr>
-    <a:masterClrMapping/>
-  </p:clrMapOvr>
-</p:notes>
-</file>
-
-<file path=ppt/notesSlides/notesSlide6.xml><?xml version="1.0" encoding="utf-8"?>
-<p:notes xmlns:a="http://schemas.openxmlformats.org/drawingml/2006/main" xmlns:r="http://schemas.openxmlformats.org/officeDocument/2006/relationships" xmlns:p="http://schemas.openxmlformats.org/presentationml/2006/main">
-  <p:cSld>
-    <p:spTree>
-      <p:nvGrpSpPr>
-        <p:cNvPr id="1" name=""/>
-        <p:cNvGrpSpPr/>
-        <p:nvPr/>
-      </p:nvGrpSpPr>
-      <p:grpSpPr>
-        <a:xfrm>
-          <a:off x="0" y="0"/>
-          <a:ext cx="0" cy="0"/>
-          <a:chOff x="0" y="0"/>
-          <a:chExt cx="0" cy="0"/>
-        </a:xfrm>
-      </p:grpSpPr>
-      <p:sp>
-        <p:nvSpPr>
-          <p:cNvPr id="18433" name="Slide Image Placeholder 1"/>
-          <p:cNvSpPr>
-            <a:spLocks noGrp="1" noRot="1" noChangeAspect="1"/>
-          </p:cNvSpPr>
-          <p:nvPr>
-            <p:ph type="sldImg"/>
-          </p:nvPr>
-        </p:nvSpPr>
-        <p:spPr bwMode="auto">
-          <a:xfrm>
-            <a:off x="381000" y="685800"/>
-            <a:ext cx="6096000" cy="3429000"/>
-          </a:xfrm>
-          <a:noFill/>
-          <a:ln>
-            <a:solidFill>
-              <a:srgbClr val="000000"/>
-            </a:solidFill>
-            <a:miter lim="800000"/>
-            <a:headEnd/>
-            <a:tailEnd/>
-          </a:ln>
-        </p:spPr>
-      </p:sp>
-      <p:sp>
-        <p:nvSpPr>
-          <p:cNvPr id="18434" name="Notes Placeholder 2"/>
-          <p:cNvSpPr>
-            <a:spLocks noGrp="1"/>
-          </p:cNvSpPr>
-          <p:nvPr>
-            <p:ph type="body" idx="1"/>
-          </p:nvPr>
-        </p:nvSpPr>
-        <p:spPr bwMode="auto">
-          <a:noFill/>
-        </p:spPr>
-        <p:txBody>
-          <a:bodyPr wrap="square" numCol="1" anchor="t" anchorCtr="0" compatLnSpc="1">
-            <a:prstTxWarp prst="textNoShape">
-              <a:avLst/>
-            </a:prstTxWarp>
-          </a:bodyPr>
-          <a:lstStyle/>
-          <a:p>
-            <a:pPr eaLnBrk="1" hangingPunct="1">
-              <a:spcBef>
-                <a:spcPct val="0"/>
-              </a:spcBef>
-            </a:pPr>
-            <a:endParaRPr lang="en-US">
-              <a:ea typeface="ＭＳ Ｐゴシック" pitchFamily="1" charset="-128"/>
-            </a:endParaRPr>
-          </a:p>
-        </p:txBody>
-      </p:sp>
-      <p:sp>
-        <p:nvSpPr>
-          <p:cNvPr id="18435" name="Slide Number Placeholder 3"/>
-          <p:cNvSpPr>
-            <a:spLocks noGrp="1"/>
-          </p:cNvSpPr>
-          <p:nvPr>
-            <p:ph type="sldNum" sz="quarter" idx="5"/>
-          </p:nvPr>
-        </p:nvSpPr>
-        <p:spPr bwMode="auto">
-          <a:noFill/>
-          <a:ln>
-            <a:miter lim="800000"/>
-            <a:headEnd/>
-            <a:tailEnd/>
-          </a:ln>
-        </p:spPr>
-        <p:txBody>
-          <a:bodyPr/>
-          <a:lstStyle/>
-          <a:p>
-            <a:pPr marL="0" marR="0" lvl="0" indent="0" algn="r" defTabSz="457200" rtl="0" eaLnBrk="1" fontAlgn="base" latinLnBrk="0" hangingPunct="1">
-              <a:lnSpc>
-                <a:spcPct val="100000"/>
-              </a:lnSpc>
-              <a:spcBef>
-                <a:spcPct val="0"/>
-              </a:spcBef>
-              <a:spcAft>
-                <a:spcPct val="0"/>
-              </a:spcAft>
-              <a:buClrTx/>
-              <a:buSzTx/>
-              <a:buFontTx/>
-              <a:buNone/>
-              <a:tabLst/>
-              <a:defRPr/>
-            </a:pPr>
-            <a:fld id="{0CA7B74D-3791-4AC6-8451-F10DBCCCDD9A}" type="slidenum">
-              <a:rPr kumimoji="0" lang="en-US" sz="1200" b="0" i="0" u="none" strike="noStrike" kern="1200" cap="none" spc="0" normalizeH="0" baseline="0" noProof="0">
-                <a:ln>
-                  <a:noFill/>
-                </a:ln>
-                <a:solidFill>
-                  <a:prstClr val="black"/>
-                </a:solidFill>
-                <a:effectLst/>
-                <a:uLnTx/>
-                <a:uFillTx/>
-                <a:latin typeface="Calibri" pitchFamily="34" charset="0"/>
-                <a:ea typeface="ＭＳ Ｐゴシック" pitchFamily="1" charset="-128"/>
-                <a:cs typeface="+mn-cs"/>
-              </a:rPr>
-              <a:pPr marL="0" marR="0" lvl="0" indent="0" algn="r" defTabSz="457200" rtl="0" eaLnBrk="1" fontAlgn="base" latinLnBrk="0" hangingPunct="1">
-                <a:lnSpc>
-                  <a:spcPct val="100000"/>
-                </a:lnSpc>
-                <a:spcBef>
-                  <a:spcPct val="0"/>
-                </a:spcBef>
-                <a:spcAft>
-                  <a:spcPct val="0"/>
-                </a:spcAft>
-                <a:buClrTx/>
-                <a:buSzTx/>
-                <a:buFontTx/>
-                <a:buNone/>
-                <a:tabLst/>
-                <a:defRPr/>
-              </a:pPr>
-              <a:t>7</a:t>
             </a:fld>
             <a:endParaRPr kumimoji="0" lang="en-US" sz="1200" b="0" i="0" u="none" strike="noStrike" kern="1200" cap="none" spc="0" normalizeH="0" baseline="0" noProof="0">
               <a:ln>
@@ -1737,7 +1558,7 @@
           <a:p>
             <a:fld id="{E60792E3-D524-454C-8AFD-A91972900BCB}" type="datetime1">
               <a:rPr lang="en-US" smtClean="0"/>
-              <a:t>7/24/2026</a:t>
+              <a:t>7/26/2026</a:t>
             </a:fld>
             <a:endParaRPr lang="en-US"/>
           </a:p>
@@ -1919,7 +1740,7 @@
           <a:p>
             <a:fld id="{053C3A68-6922-42D3-8905-ECC2D82A3469}" type="datetime1">
               <a:rPr lang="en-US" smtClean="0"/>
-              <a:t>7/24/2026</a:t>
+              <a:t>7/26/2026</a:t>
             </a:fld>
             <a:endParaRPr lang="en-US"/>
           </a:p>
@@ -2111,7 +1932,7 @@
           <a:p>
             <a:fld id="{CB69E9F4-7604-4950-A8B2-8ACDEDB1506E}" type="datetime1">
               <a:rPr lang="en-US" smtClean="0"/>
-              <a:t>7/24/2026</a:t>
+              <a:t>7/26/2026</a:t>
             </a:fld>
             <a:endParaRPr lang="en-US"/>
           </a:p>
@@ -2293,7 +2114,7 @@
           <a:p>
             <a:fld id="{708B7524-32A2-4C20-A58C-BC3BAA1042FC}" type="datetime1">
               <a:rPr lang="en-US" smtClean="0"/>
-              <a:t>7/24/2026</a:t>
+              <a:t>7/26/2026</a:t>
             </a:fld>
             <a:endParaRPr lang="en-US"/>
           </a:p>
@@ -2552,7 +2373,7 @@
           <a:p>
             <a:fld id="{1E994447-D6B2-43BB-A877-57F1A267B999}" type="datetime1">
               <a:rPr lang="en-US" smtClean="0"/>
-              <a:t>7/24/2026</a:t>
+              <a:t>7/26/2026</a:t>
             </a:fld>
             <a:endParaRPr lang="en-US"/>
           </a:p>
@@ -2851,7 +2672,7 @@
           <a:p>
             <a:fld id="{68920E16-BD35-483C-AA6B-346FC7E46DEA}" type="datetime1">
               <a:rPr lang="en-US" smtClean="0"/>
-              <a:t>7/24/2026</a:t>
+              <a:t>7/26/2026</a:t>
             </a:fld>
             <a:endParaRPr lang="en-US"/>
           </a:p>
@@ -3284,7 +3105,7 @@
           <a:p>
             <a:fld id="{2FEAC6F8-5103-4FC0-A69E-5C6AE6469DA8}" type="datetime1">
               <a:rPr lang="en-US" smtClean="0"/>
-              <a:t>7/24/2026</a:t>
+              <a:t>7/26/2026</a:t>
             </a:fld>
             <a:endParaRPr lang="en-US"/>
           </a:p>
@@ -3415,7 +3236,7 @@
           <a:p>
             <a:fld id="{C60C6921-0627-4C8F-83D5-0CF936D2FFDD}" type="datetime1">
               <a:rPr lang="en-US" smtClean="0"/>
-              <a:t>7/24/2026</a:t>
+              <a:t>7/26/2026</a:t>
             </a:fld>
             <a:endParaRPr lang="en-US"/>
           </a:p>
@@ -3524,7 +3345,7 @@
           <a:p>
             <a:fld id="{2FF08AD7-8103-40F8-983C-E2BA6BB9CBE0}" type="datetime1">
               <a:rPr lang="en-US" smtClean="0"/>
-              <a:t>7/24/2026</a:t>
+              <a:t>7/26/2026</a:t>
             </a:fld>
             <a:endParaRPr lang="en-US"/>
           </a:p>
@@ -3813,7 +3634,7 @@
           <a:p>
             <a:fld id="{DF8C06B4-9380-4A4D-AF49-A3596E17DAF5}" type="datetime1">
               <a:rPr lang="en-US" smtClean="0"/>
-              <a:t>7/24/2026</a:t>
+              <a:t>7/26/2026</a:t>
             </a:fld>
             <a:endParaRPr lang="en-US"/>
           </a:p>
@@ -4082,7 +3903,7 @@
           <a:p>
             <a:fld id="{EF7FDEF1-C582-4E22-9E77-D68326471F28}" type="datetime1">
               <a:rPr lang="en-US" smtClean="0"/>
-              <a:t>7/24/2026</a:t>
+              <a:t>7/26/2026</a:t>
             </a:fld>
             <a:endParaRPr lang="en-US"/>
           </a:p>
@@ -4325,7 +4146,7 @@
           <a:p>
             <a:fld id="{780A9602-A9A9-453F-AEF1-37B5837E02CD}" type="datetime1">
               <a:rPr lang="en-US" smtClean="0"/>
-              <a:t>7/24/2026</a:t>
+              <a:t>7/26/2026</a:t>
             </a:fld>
             <a:endParaRPr lang="en-US"/>
           </a:p>
@@ -4862,741 +4683,6 @@
       </p:grpSpPr>
       <p:sp>
         <p:nvSpPr>
-          <p:cNvPr id="6" name="Slide Number Placeholder 5"/>
-          <p:cNvSpPr>
-            <a:spLocks noGrp="1"/>
-          </p:cNvSpPr>
-          <p:nvPr>
-            <p:ph type="sldNum" sz="quarter" idx="12"/>
-          </p:nvPr>
-        </p:nvSpPr>
-        <p:spPr/>
-        <p:txBody>
-          <a:bodyPr/>
-          <a:lstStyle/>
-          <a:p>
-            <a:pPr marL="0" marR="0" lvl="0" indent="0" algn="r" defTabSz="457200" rtl="0" eaLnBrk="1" fontAlgn="base" latinLnBrk="0" hangingPunct="1">
-              <a:lnSpc>
-                <a:spcPct val="100000"/>
-              </a:lnSpc>
-              <a:spcBef>
-                <a:spcPct val="0"/>
-              </a:spcBef>
-              <a:spcAft>
-                <a:spcPct val="0"/>
-              </a:spcAft>
-              <a:buClrTx/>
-              <a:buSzTx/>
-              <a:buFontTx/>
-              <a:buNone/>
-              <a:tabLst/>
-              <a:defRPr/>
-            </a:pPr>
-            <a:fld id="{677C3CE7-23F7-4828-823C-E0205DF2CF97}" type="slidenum">
-              <a:rPr kumimoji="0" lang="en-US" sz="1200" b="1" i="0" u="none" strike="noStrike" kern="1200" cap="none" spc="0" normalizeH="0" baseline="0" noProof="0">
-                <a:ln>
-                  <a:noFill/>
-                </a:ln>
-                <a:solidFill>
-                  <a:prstClr val="white"/>
-                </a:solidFill>
-                <a:effectLst/>
-                <a:uLnTx/>
-                <a:uFillTx/>
-                <a:latin typeface="TradeGothic" pitchFamily="1" charset="0"/>
-                <a:ea typeface="ＭＳ Ｐゴシック" pitchFamily="1" charset="-128"/>
-                <a:cs typeface="+mn-cs"/>
-              </a:rPr>
-              <a:pPr marL="0" marR="0" lvl="0" indent="0" algn="r" defTabSz="457200" rtl="0" eaLnBrk="1" fontAlgn="base" latinLnBrk="0" hangingPunct="1">
-                <a:lnSpc>
-                  <a:spcPct val="100000"/>
-                </a:lnSpc>
-                <a:spcBef>
-                  <a:spcPct val="0"/>
-                </a:spcBef>
-                <a:spcAft>
-                  <a:spcPct val="0"/>
-                </a:spcAft>
-                <a:buClrTx/>
-                <a:buSzTx/>
-                <a:buFontTx/>
-                <a:buNone/>
-                <a:tabLst/>
-                <a:defRPr/>
-              </a:pPr>
-              <a:t>1</a:t>
-            </a:fld>
-            <a:endParaRPr kumimoji="0" lang="en-US" sz="1200" b="1" i="0" u="none" strike="noStrike" kern="1200" cap="none" spc="0" normalizeH="0" baseline="0" noProof="0" dirty="0">
-              <a:ln>
-                <a:noFill/>
-              </a:ln>
-              <a:solidFill>
-                <a:prstClr val="white"/>
-              </a:solidFill>
-              <a:effectLst/>
-              <a:uLnTx/>
-              <a:uFillTx/>
-              <a:latin typeface="TradeGothic" pitchFamily="1" charset="0"/>
-              <a:ea typeface="ＭＳ Ｐゴシック" pitchFamily="1" charset="-128"/>
-              <a:cs typeface="+mn-cs"/>
-            </a:endParaRPr>
-          </a:p>
-        </p:txBody>
-      </p:sp>
-      <p:sp>
-        <p:nvSpPr>
-          <p:cNvPr id="7" name="Footer Placeholder 6"/>
-          <p:cNvSpPr>
-            <a:spLocks noGrp="1"/>
-          </p:cNvSpPr>
-          <p:nvPr>
-            <p:ph type="ftr" sz="quarter" idx="11"/>
-          </p:nvPr>
-        </p:nvSpPr>
-        <p:spPr>
-          <a:xfrm>
-            <a:off x="4648200" y="6356353"/>
-            <a:ext cx="3204000" cy="365125"/>
-          </a:xfrm>
-        </p:spPr>
-        <p:txBody>
-          <a:bodyPr/>
-          <a:lstStyle/>
-          <a:p>
-            <a:pPr marL="0" marR="0" lvl="0" indent="0" algn="ctr" defTabSz="457200" rtl="0" eaLnBrk="1" fontAlgn="auto" latinLnBrk="0" hangingPunct="1">
-              <a:lnSpc>
-                <a:spcPct val="100000"/>
-              </a:lnSpc>
-              <a:spcBef>
-                <a:spcPts val="0"/>
-              </a:spcBef>
-              <a:spcAft>
-                <a:spcPts val="0"/>
-              </a:spcAft>
-              <a:buClrTx/>
-              <a:buSzTx/>
-              <a:buFontTx/>
-              <a:buNone/>
-              <a:tabLst/>
-              <a:defRPr/>
-            </a:pPr>
-            <a:r>
-              <a:rPr kumimoji="0" lang="en-US" sz="1200" b="0" i="0" u="none" strike="noStrike" kern="1200" cap="none" spc="0" normalizeH="0" baseline="0" noProof="0">
-                <a:ln>
-                  <a:noFill/>
-                </a:ln>
-                <a:solidFill>
-                  <a:prstClr val="white"/>
-                </a:solidFill>
-                <a:effectLst/>
-                <a:uLnTx/>
-                <a:uFillTx/>
-                <a:latin typeface="TradeGothic"/>
-                <a:ea typeface="+mn-ea"/>
-                <a:cs typeface="+mn-cs"/>
-              </a:rPr>
-              <a:t>@SIH Idea submission- Template</a:t>
-            </a:r>
-            <a:endParaRPr kumimoji="0" lang="en-US" sz="1200" b="0" i="0" u="none" strike="noStrike" kern="1200" cap="none" spc="0" normalizeH="0" baseline="0" noProof="0" dirty="0">
-              <a:ln>
-                <a:noFill/>
-              </a:ln>
-              <a:solidFill>
-                <a:prstClr val="white"/>
-              </a:solidFill>
-              <a:effectLst/>
-              <a:uLnTx/>
-              <a:uFillTx/>
-              <a:latin typeface="TradeGothic"/>
-              <a:ea typeface="+mn-ea"/>
-              <a:cs typeface="+mn-cs"/>
-            </a:endParaRPr>
-          </a:p>
-        </p:txBody>
-      </p:sp>
-      <p:sp>
-        <p:nvSpPr>
-          <p:cNvPr id="12" name="Google Shape;100;p3"/>
-          <p:cNvSpPr txBox="1"/>
-          <p:nvPr/>
-        </p:nvSpPr>
-        <p:spPr>
-          <a:xfrm>
-            <a:off x="367832" y="1915454"/>
-            <a:ext cx="11764736" cy="4070356"/>
-          </a:xfrm>
-          <a:prstGeom prst="rect">
-            <a:avLst/>
-          </a:prstGeom>
-          <a:noFill/>
-          <a:ln>
-            <a:noFill/>
-          </a:ln>
-        </p:spPr>
-        <p:txBody>
-          <a:bodyPr spcFirstLastPara="1" wrap="square" lIns="91425" tIns="45700" rIns="91425" bIns="45700" anchor="t" anchorCtr="0">
-            <a:noAutofit/>
-          </a:bodyPr>
-          <a:lstStyle/>
-          <a:p>
-            <a:pPr marL="914400" marR="0" lvl="1" indent="-316230" algn="just" rtl="0">
-              <a:lnSpc>
-                <a:spcPct val="90000"/>
-              </a:lnSpc>
-              <a:spcBef>
-                <a:spcPts val="500"/>
-              </a:spcBef>
-              <a:spcAft>
-                <a:spcPts val="0"/>
-              </a:spcAft>
-              <a:buClr>
-                <a:schemeClr val="dk1"/>
-              </a:buClr>
-              <a:buSzPct val="100000"/>
-              <a:buFont typeface="Calibri"/>
-              <a:buNone/>
-            </a:pPr>
-            <a:endParaRPr sz="2000" b="1" i="0" u="none" strike="noStrike" cap="none" dirty="0">
-              <a:solidFill>
-                <a:schemeClr val="dk1"/>
-              </a:solidFill>
-              <a:latin typeface="Arial" panose="020B0604020202020204" pitchFamily="34" charset="0"/>
-              <a:ea typeface="Calibri"/>
-              <a:cs typeface="Arial" panose="020B0604020202020204" pitchFamily="34" charset="0"/>
-              <a:sym typeface="Calibri"/>
-            </a:endParaRPr>
-          </a:p>
-        </p:txBody>
-      </p:sp>
-      <p:sp>
-        <p:nvSpPr>
-          <p:cNvPr id="4" name="TextBox 3"/>
-          <p:cNvSpPr txBox="1"/>
-          <p:nvPr/>
-        </p:nvSpPr>
-        <p:spPr>
-          <a:xfrm>
-            <a:off x="1393371" y="107066"/>
-            <a:ext cx="8410540" cy="646331"/>
-          </a:xfrm>
-          <a:prstGeom prst="rect">
-            <a:avLst/>
-          </a:prstGeom>
-          <a:noFill/>
-        </p:spPr>
-        <p:txBody>
-          <a:bodyPr wrap="square" rtlCol="0">
-            <a:spAutoFit/>
-          </a:bodyPr>
-          <a:lstStyle/>
-          <a:p>
-            <a:pPr algn="ctr"/>
-            <a:r>
-              <a:rPr lang="en-US" sz="3600" b="1" dirty="0">
-                <a:latin typeface="Times New Roman" panose="02020603050405020304" pitchFamily="18" charset="0"/>
-                <a:cs typeface="Times New Roman" panose="02020603050405020304" pitchFamily="18" charset="0"/>
-              </a:rPr>
-              <a:t>IMPORTANT INSTRUCTIONS</a:t>
-            </a:r>
-            <a:endParaRPr lang="en-IN" sz="3600" b="1" dirty="0">
-              <a:latin typeface="Times New Roman" panose="02020603050405020304" pitchFamily="18" charset="0"/>
-              <a:cs typeface="Times New Roman" panose="02020603050405020304" pitchFamily="18" charset="0"/>
-            </a:endParaRPr>
-          </a:p>
-        </p:txBody>
-      </p:sp>
-      <p:sp>
-        <p:nvSpPr>
-          <p:cNvPr id="5" name="TextBox 4"/>
-          <p:cNvSpPr txBox="1"/>
-          <p:nvPr/>
-        </p:nvSpPr>
-        <p:spPr>
-          <a:xfrm>
-            <a:off x="602343" y="1181900"/>
-            <a:ext cx="9557657" cy="341632"/>
-          </a:xfrm>
-          <a:prstGeom prst="rect">
-            <a:avLst/>
-          </a:prstGeom>
-          <a:noFill/>
-        </p:spPr>
-        <p:txBody>
-          <a:bodyPr wrap="square" rtlCol="0">
-            <a:spAutoFit/>
-          </a:bodyPr>
-          <a:lstStyle/>
-          <a:p>
-            <a:pPr algn="just">
-              <a:lnSpc>
-                <a:spcPct val="90000"/>
-              </a:lnSpc>
-              <a:spcBef>
-                <a:spcPts val="1000"/>
-              </a:spcBef>
-              <a:spcAft>
-                <a:spcPts val="0"/>
-              </a:spcAft>
-              <a:buClr>
-                <a:schemeClr val="dk1"/>
-              </a:buClr>
-              <a:buSzPct val="100000"/>
-            </a:pPr>
-            <a:r>
-              <a:rPr lang="en-US" b="1" dirty="0">
-                <a:solidFill>
-                  <a:schemeClr val="dk1"/>
-                </a:solidFill>
-                <a:latin typeface="Arial" panose="020B0604020202020204" pitchFamily="34" charset="0"/>
-                <a:ea typeface="Calibri"/>
-                <a:cs typeface="Arial" panose="020B0604020202020204" pitchFamily="34" charset="0"/>
-              </a:rPr>
-              <a:t>Please ensure below pointers are met while submitting the Idea PPT:</a:t>
-            </a:r>
-            <a:endParaRPr lang="en-IN" b="1" dirty="0">
-              <a:solidFill>
-                <a:schemeClr val="dk1"/>
-              </a:solidFill>
-              <a:latin typeface="Arial" panose="020B0604020202020204" pitchFamily="34" charset="0"/>
-              <a:ea typeface="Calibri"/>
-              <a:cs typeface="Arial" panose="020B0604020202020204" pitchFamily="34" charset="0"/>
-            </a:endParaRPr>
-          </a:p>
-        </p:txBody>
-      </p:sp>
-      <p:sp>
-        <p:nvSpPr>
-          <p:cNvPr id="9" name="TextBox 8">
-            <a:extLst>
-              <a:ext uri="{FF2B5EF4-FFF2-40B4-BE49-F238E27FC236}">
-                <a16:creationId xmlns:a16="http://schemas.microsoft.com/office/drawing/2014/main" id="{327CE727-C45C-A6F5-9EE5-AF363B2ADA27}"/>
-              </a:ext>
-            </a:extLst>
-          </p:cNvPr>
-          <p:cNvSpPr txBox="1"/>
-          <p:nvPr/>
-        </p:nvSpPr>
-        <p:spPr>
-          <a:xfrm>
-            <a:off x="602343" y="1714078"/>
-            <a:ext cx="10397765" cy="4073423"/>
-          </a:xfrm>
-          <a:prstGeom prst="rect">
-            <a:avLst/>
-          </a:prstGeom>
-          <a:noFill/>
-        </p:spPr>
-        <p:txBody>
-          <a:bodyPr wrap="square">
-            <a:spAutoFit/>
-          </a:bodyPr>
-          <a:lstStyle/>
-          <a:p>
-            <a:pPr marL="514350" marR="0" lvl="0" indent="-514350" algn="just" rtl="0">
-              <a:lnSpc>
-                <a:spcPct val="90000"/>
-              </a:lnSpc>
-              <a:spcBef>
-                <a:spcPts val="0"/>
-              </a:spcBef>
-              <a:spcAft>
-                <a:spcPts val="0"/>
-              </a:spcAft>
-              <a:buClr>
-                <a:schemeClr val="dk1"/>
-              </a:buClr>
-              <a:buSzPct val="100000"/>
-              <a:buFont typeface="Calibri"/>
-              <a:buAutoNum type="arabicPeriod"/>
-            </a:pPr>
-            <a:r>
-              <a:rPr lang="en-US" b="1" i="0" u="none" strike="noStrike" cap="none" dirty="0">
-                <a:solidFill>
-                  <a:schemeClr val="dk1"/>
-                </a:solidFill>
-                <a:latin typeface="Arial" panose="020B0604020202020204" pitchFamily="34" charset="0"/>
-                <a:ea typeface="Calibri"/>
-                <a:cs typeface="Arial" panose="020B0604020202020204" pitchFamily="34" charset="0"/>
-                <a:sym typeface="Calibri"/>
-              </a:rPr>
-              <a:t>Kindly keep the maximum slides limit up to six </a:t>
-            </a:r>
-            <a:r>
-              <a:rPr lang="en-US" b="1" i="0" u="none" strike="noStrike" cap="none" dirty="0">
-                <a:solidFill>
-                  <a:srgbClr val="C00000"/>
-                </a:solidFill>
-                <a:latin typeface="Arial" panose="020B0604020202020204" pitchFamily="34" charset="0"/>
-                <a:ea typeface="Calibri"/>
-                <a:cs typeface="Arial" panose="020B0604020202020204" pitchFamily="34" charset="0"/>
-                <a:sym typeface="Calibri"/>
-              </a:rPr>
-              <a:t>(6). </a:t>
-            </a:r>
-            <a:r>
-              <a:rPr lang="en-US" b="1" i="0" u="none" strike="noStrike" cap="none" dirty="0">
-                <a:solidFill>
-                  <a:schemeClr val="dk1"/>
-                </a:solidFill>
-                <a:latin typeface="Arial" panose="020B0604020202020204" pitchFamily="34" charset="0"/>
-                <a:ea typeface="Calibri"/>
-                <a:cs typeface="Arial" panose="020B0604020202020204" pitchFamily="34" charset="0"/>
-                <a:sym typeface="Calibri"/>
-              </a:rPr>
-              <a:t>( Including the title slide) </a:t>
-            </a:r>
-            <a:endParaRPr lang="en-US" b="1" dirty="0">
-              <a:latin typeface="Arial" panose="020B0604020202020204" pitchFamily="34" charset="0"/>
-              <a:cs typeface="Arial" panose="020B0604020202020204" pitchFamily="34" charset="0"/>
-            </a:endParaRPr>
-          </a:p>
-          <a:p>
-            <a:pPr marL="514350" marR="0" lvl="0" indent="-514350" algn="just" rtl="0">
-              <a:lnSpc>
-                <a:spcPct val="90000"/>
-              </a:lnSpc>
-              <a:spcBef>
-                <a:spcPts val="1000"/>
-              </a:spcBef>
-              <a:spcAft>
-                <a:spcPts val="0"/>
-              </a:spcAft>
-              <a:buClr>
-                <a:schemeClr val="dk1"/>
-              </a:buClr>
-              <a:buSzPct val="100000"/>
-              <a:buFont typeface="Calibri"/>
-              <a:buAutoNum type="arabicPeriod"/>
-            </a:pPr>
-            <a:r>
-              <a:rPr lang="en-US" b="1" i="0" u="none" strike="noStrike" cap="none" dirty="0">
-                <a:solidFill>
-                  <a:schemeClr val="dk1"/>
-                </a:solidFill>
-                <a:latin typeface="Arial" panose="020B0604020202020204" pitchFamily="34" charset="0"/>
-                <a:ea typeface="Calibri"/>
-                <a:cs typeface="Arial" panose="020B0604020202020204" pitchFamily="34" charset="0"/>
-                <a:sym typeface="Calibri"/>
-              </a:rPr>
-              <a:t>Try to avoid paragraphs and post your idea in points /diagrams / Infographics /pictures </a:t>
-            </a:r>
-            <a:endParaRPr lang="en-US" b="1" dirty="0">
-              <a:latin typeface="Arial" panose="020B0604020202020204" pitchFamily="34" charset="0"/>
-              <a:cs typeface="Arial" panose="020B0604020202020204" pitchFamily="34" charset="0"/>
-            </a:endParaRPr>
-          </a:p>
-          <a:p>
-            <a:pPr marL="514350" marR="0" lvl="0" indent="-514350" algn="just" rtl="0">
-              <a:lnSpc>
-                <a:spcPct val="90000"/>
-              </a:lnSpc>
-              <a:spcBef>
-                <a:spcPts val="1000"/>
-              </a:spcBef>
-              <a:spcAft>
-                <a:spcPts val="0"/>
-              </a:spcAft>
-              <a:buClr>
-                <a:schemeClr val="dk1"/>
-              </a:buClr>
-              <a:buSzPct val="100000"/>
-              <a:buFont typeface="Calibri"/>
-              <a:buAutoNum type="arabicPeriod"/>
-            </a:pPr>
-            <a:r>
-              <a:rPr lang="en-US" b="1" i="0" u="none" strike="noStrike" cap="none" dirty="0">
-                <a:solidFill>
-                  <a:schemeClr val="dk1"/>
-                </a:solidFill>
-                <a:latin typeface="Arial" panose="020B0604020202020204" pitchFamily="34" charset="0"/>
-                <a:ea typeface="Calibri"/>
-                <a:cs typeface="Arial" panose="020B0604020202020204" pitchFamily="34" charset="0"/>
-                <a:sym typeface="Calibri"/>
-              </a:rPr>
-              <a:t>Keep your explanation precise and easy to understand</a:t>
-            </a:r>
-            <a:endParaRPr lang="en-US" b="1" dirty="0">
-              <a:latin typeface="Arial" panose="020B0604020202020204" pitchFamily="34" charset="0"/>
-              <a:cs typeface="Arial" panose="020B0604020202020204" pitchFamily="34" charset="0"/>
-            </a:endParaRPr>
-          </a:p>
-          <a:p>
-            <a:pPr marL="514350" marR="0" lvl="0" indent="-514350" algn="just" rtl="0">
-              <a:lnSpc>
-                <a:spcPct val="90000"/>
-              </a:lnSpc>
-              <a:spcBef>
-                <a:spcPts val="1000"/>
-              </a:spcBef>
-              <a:spcAft>
-                <a:spcPts val="0"/>
-              </a:spcAft>
-              <a:buClr>
-                <a:schemeClr val="dk1"/>
-              </a:buClr>
-              <a:buSzPct val="100000"/>
-              <a:buFont typeface="Calibri"/>
-              <a:buAutoNum type="arabicPeriod"/>
-            </a:pPr>
-            <a:r>
-              <a:rPr lang="en-US" b="1" i="0" u="none" strike="noStrike" cap="none" dirty="0">
-                <a:solidFill>
-                  <a:schemeClr val="dk1"/>
-                </a:solidFill>
-                <a:latin typeface="Arial" panose="020B0604020202020204" pitchFamily="34" charset="0"/>
-                <a:ea typeface="Calibri"/>
-                <a:cs typeface="Arial" panose="020B0604020202020204" pitchFamily="34" charset="0"/>
-                <a:sym typeface="Calibri"/>
-              </a:rPr>
-              <a:t>Idea should be unique and novel. </a:t>
-            </a:r>
-            <a:endParaRPr lang="en-US" b="1" dirty="0">
-              <a:latin typeface="Arial" panose="020B0604020202020204" pitchFamily="34" charset="0"/>
-              <a:cs typeface="Arial" panose="020B0604020202020204" pitchFamily="34" charset="0"/>
-            </a:endParaRPr>
-          </a:p>
-          <a:p>
-            <a:pPr marL="514350" marR="0" lvl="0" indent="-514350" algn="just" rtl="0">
-              <a:lnSpc>
-                <a:spcPct val="90000"/>
-              </a:lnSpc>
-              <a:spcBef>
-                <a:spcPts val="1000"/>
-              </a:spcBef>
-              <a:spcAft>
-                <a:spcPts val="0"/>
-              </a:spcAft>
-              <a:buClr>
-                <a:schemeClr val="dk1"/>
-              </a:buClr>
-              <a:buSzPct val="100000"/>
-              <a:buFont typeface="Calibri"/>
-              <a:buAutoNum type="arabicPeriod"/>
-            </a:pPr>
-            <a:r>
-              <a:rPr lang="en-US" b="1" i="0" u="none" strike="noStrike" cap="none" dirty="0">
-                <a:solidFill>
-                  <a:schemeClr val="dk1"/>
-                </a:solidFill>
-                <a:latin typeface="Arial" panose="020B0604020202020204" pitchFamily="34" charset="0"/>
-                <a:ea typeface="Calibri"/>
-                <a:cs typeface="Arial" panose="020B0604020202020204" pitchFamily="34" charset="0"/>
-                <a:sym typeface="Calibri"/>
-              </a:rPr>
-              <a:t>You can only use provided </a:t>
-            </a:r>
-            <a:r>
-              <a:rPr lang="en-US" b="1" dirty="0">
-                <a:solidFill>
-                  <a:schemeClr val="dk1"/>
-                </a:solidFill>
-                <a:latin typeface="Arial" panose="020B0604020202020204" pitchFamily="34" charset="0"/>
-                <a:ea typeface="Calibri"/>
-                <a:cs typeface="Arial" panose="020B0604020202020204" pitchFamily="34" charset="0"/>
-                <a:sym typeface="Calibri"/>
-              </a:rPr>
-              <a:t>template</a:t>
-            </a:r>
-            <a:r>
-              <a:rPr lang="en-US" b="1" i="0" u="none" strike="noStrike" cap="none" dirty="0">
-                <a:solidFill>
-                  <a:schemeClr val="dk1"/>
-                </a:solidFill>
-                <a:latin typeface="Arial" panose="020B0604020202020204" pitchFamily="34" charset="0"/>
-                <a:ea typeface="Calibri"/>
-                <a:cs typeface="Arial" panose="020B0604020202020204" pitchFamily="34" charset="0"/>
-                <a:sym typeface="Calibri"/>
-              </a:rPr>
-              <a:t> for making the </a:t>
-            </a:r>
-            <a:r>
-              <a:rPr lang="en-US" b="1" dirty="0">
-                <a:solidFill>
-                  <a:schemeClr val="dk1"/>
-                </a:solidFill>
-                <a:latin typeface="Arial" panose="020B0604020202020204" pitchFamily="34" charset="0"/>
-                <a:ea typeface="Calibri"/>
-                <a:cs typeface="Arial" panose="020B0604020202020204" pitchFamily="34" charset="0"/>
-                <a:sym typeface="Calibri"/>
-              </a:rPr>
-              <a:t>PPT</a:t>
-            </a:r>
-            <a:r>
-              <a:rPr lang="en-US" b="1" i="0" u="none" strike="noStrike" cap="none" dirty="0">
-                <a:solidFill>
-                  <a:schemeClr val="dk1"/>
-                </a:solidFill>
-                <a:latin typeface="Arial" panose="020B0604020202020204" pitchFamily="34" charset="0"/>
-                <a:ea typeface="Calibri"/>
-                <a:cs typeface="Arial" panose="020B0604020202020204" pitchFamily="34" charset="0"/>
-                <a:sym typeface="Calibri"/>
-              </a:rPr>
-              <a:t> without changing the idea details pointers (mentioned in previous slides).</a:t>
-            </a:r>
-          </a:p>
-          <a:p>
-            <a:pPr marL="514350" marR="0" lvl="0" indent="-514350" algn="just" rtl="0">
-              <a:lnSpc>
-                <a:spcPct val="90000"/>
-              </a:lnSpc>
-              <a:spcBef>
-                <a:spcPts val="1000"/>
-              </a:spcBef>
-              <a:spcAft>
-                <a:spcPts val="0"/>
-              </a:spcAft>
-              <a:buClr>
-                <a:schemeClr val="dk1"/>
-              </a:buClr>
-              <a:buSzPct val="100000"/>
-              <a:buFont typeface="Calibri"/>
-              <a:buAutoNum type="arabicPeriod"/>
-            </a:pPr>
-            <a:r>
-              <a:rPr lang="en-US" b="1" i="0" u="none" strike="noStrike" cap="none" dirty="0">
-                <a:solidFill>
-                  <a:schemeClr val="dk1"/>
-                </a:solidFill>
-                <a:latin typeface="Arial" panose="020B0604020202020204" pitchFamily="34" charset="0"/>
-                <a:ea typeface="Calibri"/>
-                <a:cs typeface="Arial" panose="020B0604020202020204" pitchFamily="34" charset="0"/>
-                <a:sym typeface="Calibri"/>
-              </a:rPr>
-              <a:t>You need to save the file in PDF and upload the same on portal. No PPT, Word Doc or any other format will be supported.</a:t>
-            </a:r>
-            <a:endParaRPr lang="en-US" b="1" dirty="0">
-              <a:latin typeface="Arial" panose="020B0604020202020204" pitchFamily="34" charset="0"/>
-              <a:cs typeface="Arial" panose="020B0604020202020204" pitchFamily="34" charset="0"/>
-            </a:endParaRPr>
-          </a:p>
-          <a:p>
-            <a:pPr marL="514350" marR="0" lvl="0" indent="-349885" algn="just" rtl="0">
-              <a:lnSpc>
-                <a:spcPct val="90000"/>
-              </a:lnSpc>
-              <a:spcBef>
-                <a:spcPts val="1000"/>
-              </a:spcBef>
-              <a:spcAft>
-                <a:spcPts val="0"/>
-              </a:spcAft>
-              <a:buClr>
-                <a:schemeClr val="dk1"/>
-              </a:buClr>
-              <a:buSzPct val="100000"/>
-              <a:buFont typeface="Calibri"/>
-              <a:buNone/>
-            </a:pPr>
-            <a:endParaRPr lang="en-US" b="1" i="0" u="none" strike="noStrike" cap="none" dirty="0">
-              <a:solidFill>
-                <a:schemeClr val="dk1"/>
-              </a:solidFill>
-              <a:latin typeface="Arial" panose="020B0604020202020204" pitchFamily="34" charset="0"/>
-              <a:ea typeface="Calibri"/>
-              <a:cs typeface="Arial" panose="020B0604020202020204" pitchFamily="34" charset="0"/>
-              <a:sym typeface="Calibri"/>
-            </a:endParaRPr>
-          </a:p>
-          <a:p>
-            <a:pPr marL="0" marR="0" lvl="0" indent="0" algn="just" rtl="0">
-              <a:lnSpc>
-                <a:spcPct val="90000"/>
-              </a:lnSpc>
-              <a:spcBef>
-                <a:spcPts val="1000"/>
-              </a:spcBef>
-              <a:spcAft>
-                <a:spcPts val="0"/>
-              </a:spcAft>
-              <a:buClr>
-                <a:schemeClr val="dk1"/>
-              </a:buClr>
-              <a:buSzPct val="100000"/>
-              <a:buFont typeface="Arial"/>
-              <a:buNone/>
-            </a:pPr>
-            <a:r>
-              <a:rPr lang="en-US" b="1" i="0" u="none" strike="noStrike" cap="none" dirty="0">
-                <a:solidFill>
-                  <a:srgbClr val="C00000"/>
-                </a:solidFill>
-                <a:latin typeface="Arial" panose="020B0604020202020204" pitchFamily="34" charset="0"/>
-                <a:ea typeface="Calibri"/>
-                <a:cs typeface="Arial" panose="020B0604020202020204" pitchFamily="34" charset="0"/>
-                <a:sym typeface="Calibri"/>
-              </a:rPr>
-              <a:t>Note - You can delete this slide (Important Pointers) when you upload the details of your idea portal.</a:t>
-            </a:r>
-            <a:endParaRPr lang="en-US" b="1" dirty="0">
-              <a:solidFill>
-                <a:srgbClr val="C00000"/>
-              </a:solidFill>
-              <a:latin typeface="Arial" panose="020B0604020202020204" pitchFamily="34" charset="0"/>
-              <a:cs typeface="Arial" panose="020B0604020202020204" pitchFamily="34" charset="0"/>
-            </a:endParaRPr>
-          </a:p>
-          <a:p>
-            <a:pPr marL="914400" marR="0" lvl="1" indent="-316230" algn="just" rtl="0">
-              <a:lnSpc>
-                <a:spcPct val="90000"/>
-              </a:lnSpc>
-              <a:spcBef>
-                <a:spcPts val="500"/>
-              </a:spcBef>
-              <a:spcAft>
-                <a:spcPts val="0"/>
-              </a:spcAft>
-              <a:buClr>
-                <a:schemeClr val="dk1"/>
-              </a:buClr>
-              <a:buSzPct val="100000"/>
-              <a:buFont typeface="Calibri"/>
-              <a:buNone/>
-            </a:pPr>
-            <a:endParaRPr lang="en-US" sz="2000" b="1" i="0" u="none" strike="noStrike" cap="none" dirty="0">
-              <a:solidFill>
-                <a:schemeClr val="dk1"/>
-              </a:solidFill>
-              <a:latin typeface="Arial" panose="020B0604020202020204" pitchFamily="34" charset="0"/>
-              <a:ea typeface="Calibri"/>
-              <a:cs typeface="Arial" panose="020B0604020202020204" pitchFamily="34" charset="0"/>
-              <a:sym typeface="Calibri"/>
-            </a:endParaRPr>
-          </a:p>
-        </p:txBody>
-      </p:sp>
-    </p:spTree>
-    <p:extLst>
-      <p:ext uri="{BB962C8B-B14F-4D97-AF65-F5344CB8AC3E}">
-        <p14:creationId xmlns:p14="http://schemas.microsoft.com/office/powerpoint/2010/main" val="1588084416"/>
-      </p:ext>
-    </p:extLst>
-  </p:cSld>
-  <p:clrMapOvr>
-    <a:masterClrMapping/>
-  </p:clrMapOvr>
-</p:sld>
-</file>
-
-<file path=ppt/slides/slide2.xml><?xml version="1.0" encoding="utf-8"?>
-<p:sld xmlns:a="http://schemas.openxmlformats.org/drawingml/2006/main" xmlns:r="http://schemas.openxmlformats.org/officeDocument/2006/relationships" xmlns:p="http://schemas.openxmlformats.org/presentationml/2006/main">
-  <p:cSld>
-    <p:spTree>
-      <p:nvGrpSpPr>
-        <p:cNvPr id="1" name=""/>
-        <p:cNvGrpSpPr/>
-        <p:nvPr/>
-      </p:nvGrpSpPr>
-      <p:grpSpPr>
-        <a:xfrm>
-          <a:off x="0" y="0"/>
-          <a:ext cx="0" cy="0"/>
-          <a:chOff x="0" y="0"/>
-          <a:chExt cx="0" cy="0"/>
-        </a:xfrm>
-      </p:grpSpPr>
-      <p:sp>
-        <p:nvSpPr>
           <p:cNvPr id="4" name="Footer Placeholder 3">
             <a:extLst>
               <a:ext uri="{FF2B5EF4-FFF2-40B4-BE49-F238E27FC236}">
@@ -5650,7 +4736,7 @@
             <a:fld id="{677C3CE7-23F7-4828-823C-E0205DF2CF97}" type="slidenum">
               <a:rPr lang="en-US" smtClean="0"/>
               <a:pPr/>
-              <a:t>2</a:t>
+              <a:t>1</a:t>
             </a:fld>
             <a:endParaRPr lang="en-US"/>
           </a:p>
@@ -5906,8 +4992,8 @@
         </p:nvSpPr>
         <p:spPr>
           <a:xfrm>
-            <a:off x="397274" y="1203454"/>
-            <a:ext cx="5924550" cy="4686668"/>
+            <a:off x="397273" y="1203454"/>
+            <a:ext cx="11054205" cy="4686668"/>
           </a:xfrm>
           <a:prstGeom prst="rect">
             <a:avLst/>
@@ -5935,7 +5021,7 @@
                 <a:latin typeface="Arial" panose="020B0604020202020204" pitchFamily="34" charset="0"/>
                 <a:cs typeface="Arial" panose="020B0604020202020204" pitchFamily="34" charset="0"/>
               </a:rPr>
-              <a:t>Problem Statement ID –</a:t>
+              <a:t>Problem Statement ID- 1</a:t>
             </a:r>
           </a:p>
           <a:p>
@@ -5951,7 +5037,7 @@
                 <a:latin typeface="Arial" panose="020B0604020202020204" pitchFamily="34" charset="0"/>
                 <a:cs typeface="Arial" panose="020B0604020202020204" pitchFamily="34" charset="0"/>
               </a:rPr>
-              <a:t>Problem Statement Title-</a:t>
+              <a:t>Problem Statement Title- Eco-Loop Building Agent</a:t>
             </a:r>
           </a:p>
           <a:p>
@@ -5967,7 +5053,7 @@
                 <a:latin typeface="Arial" panose="020B0604020202020204" pitchFamily="34" charset="0"/>
                 <a:cs typeface="Arial" panose="020B0604020202020204" pitchFamily="34" charset="0"/>
               </a:rPr>
-              <a:t>Theme-</a:t>
+              <a:t>Theme- Smart Building Automation Agent, Industrial AI, Sustainability</a:t>
             </a:r>
           </a:p>
           <a:p>
@@ -5983,7 +5069,7 @@
                 <a:latin typeface="Arial" panose="020B0604020202020204" pitchFamily="34" charset="0"/>
                 <a:cs typeface="Arial" panose="020B0604020202020204" pitchFamily="34" charset="0"/>
               </a:rPr>
-              <a:t>PS Category- Software/Hardware</a:t>
+              <a:t>PS Category- Software</a:t>
             </a:r>
           </a:p>
           <a:p>
@@ -5999,7 +5085,7 @@
                 <a:latin typeface="Arial" panose="020B0604020202020204" pitchFamily="34" charset="0"/>
                 <a:cs typeface="Arial" panose="020B0604020202020204" pitchFamily="34" charset="0"/>
               </a:rPr>
-              <a:t>Student Name (Registered on portal)</a:t>
+              <a:t>Student Name (Registered on portal) – Raj Kokate</a:t>
             </a:r>
           </a:p>
           <a:p>
@@ -6015,7 +5101,7 @@
                 <a:latin typeface="Arial" panose="020B0604020202020204" pitchFamily="34" charset="0"/>
                 <a:cs typeface="Arial" panose="020B0604020202020204" pitchFamily="34" charset="0"/>
               </a:rPr>
-              <a:t>Student ID</a:t>
+              <a:t>Student ID- 23BIT0269</a:t>
             </a:r>
             <a:endParaRPr lang="en-IN" sz="2400" b="1" dirty="0">
               <a:latin typeface="Arial" panose="020B0604020202020204" pitchFamily="34" charset="0"/>
@@ -6030,6 +5116,434 @@
         <p14:creationId xmlns:p14="http://schemas.microsoft.com/office/powerpoint/2010/main" val="3319884780"/>
       </p:ext>
     </p:extLst>
+  </p:cSld>
+  <p:clrMapOvr>
+    <a:masterClrMapping/>
+  </p:clrMapOvr>
+</p:sld>
+</file>
+
+<file path=ppt/slides/slide2.xml><?xml version="1.0" encoding="utf-8"?>
+<p:sld xmlns:a="http://schemas.openxmlformats.org/drawingml/2006/main" xmlns:r="http://schemas.openxmlformats.org/officeDocument/2006/relationships" xmlns:p="http://schemas.openxmlformats.org/presentationml/2006/main">
+  <p:cSld>
+    <p:spTree>
+      <p:nvGrpSpPr>
+        <p:cNvPr id="1" name=""/>
+        <p:cNvGrpSpPr/>
+        <p:nvPr/>
+      </p:nvGrpSpPr>
+      <p:grpSpPr>
+        <a:xfrm>
+          <a:off x="0" y="0"/>
+          <a:ext cx="0" cy="0"/>
+          <a:chOff x="0" y="0"/>
+          <a:chExt cx="0" cy="0"/>
+        </a:xfrm>
+      </p:grpSpPr>
+      <p:sp>
+        <p:nvSpPr>
+          <p:cNvPr id="15361" name="Title 1"/>
+          <p:cNvSpPr>
+            <a:spLocks noGrp="1"/>
+          </p:cNvSpPr>
+          <p:nvPr>
+            <p:ph type="title"/>
+          </p:nvPr>
+        </p:nvSpPr>
+        <p:spPr>
+          <a:xfrm>
+            <a:off x="182998" y="0"/>
+            <a:ext cx="10972800" cy="773251"/>
+          </a:xfrm>
+        </p:spPr>
+        <p:txBody>
+          <a:bodyPr/>
+          <a:lstStyle/>
+          <a:p>
+            <a:pPr eaLnBrk="1" hangingPunct="1"/>
+            <a:r>
+              <a:rPr lang="en-US" sz="3600" b="1" dirty="0">
+                <a:latin typeface="Times New Roman" panose="02020603050405020304" pitchFamily="18" charset="0"/>
+                <a:ea typeface="ＭＳ Ｐゴシック" pitchFamily="1" charset="-128"/>
+                <a:cs typeface="Times New Roman" panose="02020603050405020304" pitchFamily="18" charset="0"/>
+              </a:rPr>
+              <a:t>IDEA TITLE</a:t>
+            </a:r>
+          </a:p>
+        </p:txBody>
+      </p:sp>
+      <p:sp>
+        <p:nvSpPr>
+          <p:cNvPr id="15362" name="TextBox 8"/>
+          <p:cNvSpPr txBox="1">
+            <a:spLocks noChangeArrowheads="1"/>
+          </p:cNvSpPr>
+          <p:nvPr/>
+        </p:nvSpPr>
+        <p:spPr bwMode="auto">
+          <a:xfrm>
+            <a:off x="0" y="773251"/>
+            <a:ext cx="12191999" cy="6309420"/>
+          </a:xfrm>
+          <a:prstGeom prst="rect">
+            <a:avLst/>
+          </a:prstGeom>
+          <a:noFill/>
+          <a:ln w="9525">
+            <a:noFill/>
+            <a:miter lim="800000"/>
+            <a:headEnd/>
+            <a:tailEnd/>
+          </a:ln>
+        </p:spPr>
+        <p:txBody>
+          <a:bodyPr wrap="square">
+            <a:spAutoFit/>
+          </a:bodyPr>
+          <a:lstStyle/>
+          <a:p>
+            <a:r>
+              <a:rPr lang="en-US" sz="3200" b="1" u="sng" dirty="0">
+                <a:latin typeface="Arial" panose="020B0604020202020204" pitchFamily="34" charset="0"/>
+                <a:cs typeface="Arial" pitchFamily="34" charset="0"/>
+              </a:rPr>
+              <a:t>Proposed Solution</a:t>
+            </a:r>
+            <a:r>
+              <a:rPr lang="en-US" sz="3200" b="1" dirty="0">
+                <a:latin typeface="Arial" panose="020B0604020202020204" pitchFamily="34" charset="0"/>
+                <a:cs typeface="Arial" pitchFamily="34" charset="0"/>
+              </a:rPr>
+              <a:t> - </a:t>
+            </a:r>
+            <a:r>
+              <a:rPr lang="en-IN" sz="3200" b="1" dirty="0">
+                <a:latin typeface="Arial" panose="020B0604020202020204" pitchFamily="34" charset="0"/>
+                <a:cs typeface="Arial" panose="020B0604020202020204" pitchFamily="34" charset="0"/>
+              </a:rPr>
+              <a:t>Eco-Loop: Autonomous AI-Driven Building Energy Agent</a:t>
+            </a:r>
+            <a:endParaRPr lang="en-US" sz="2000" u="sng" dirty="0">
+              <a:solidFill>
+                <a:schemeClr val="tx2"/>
+              </a:solidFill>
+              <a:latin typeface="Arial" panose="020B0604020202020204" pitchFamily="34" charset="0"/>
+              <a:cs typeface="Arial" pitchFamily="34" charset="0"/>
+            </a:endParaRPr>
+          </a:p>
+          <a:p>
+            <a:pPr marL="342900" indent="-342900" algn="just">
+              <a:buFont typeface="Arial" panose="020B0604020202020204" pitchFamily="34" charset="0"/>
+              <a:buChar char="•"/>
+            </a:pPr>
+            <a:r>
+              <a:rPr lang="en-IN" sz="2000" dirty="0">
+                <a:latin typeface="Arial" panose="020B0604020202020204" pitchFamily="34" charset="0"/>
+                <a:cs typeface="Arial" panose="020B0604020202020204" pitchFamily="34" charset="0"/>
+              </a:rPr>
+              <a:t>Eco-Loop is an autonomous AI system that continuously monitors building conditions and optimizes HVAC operations using an LLM, </a:t>
+            </a:r>
+            <a:r>
+              <a:rPr lang="en-IN" sz="2000" dirty="0" err="1">
+                <a:latin typeface="Arial" panose="020B0604020202020204" pitchFamily="34" charset="0"/>
+                <a:cs typeface="Arial" panose="020B0604020202020204" pitchFamily="34" charset="0"/>
+              </a:rPr>
+              <a:t>EnergyPlus</a:t>
+            </a:r>
+            <a:r>
+              <a:rPr lang="en-IN" sz="2000" dirty="0">
+                <a:latin typeface="Arial" panose="020B0604020202020204" pitchFamily="34" charset="0"/>
+                <a:cs typeface="Arial" panose="020B0604020202020204" pitchFamily="34" charset="0"/>
+              </a:rPr>
+              <a:t> simulations, BACnet controllers, and real-time sensor data.</a:t>
+            </a:r>
+          </a:p>
+          <a:p>
+            <a:pPr algn="just"/>
+            <a:endParaRPr lang="en-IN" sz="2000" dirty="0">
+              <a:latin typeface="Arial" panose="020B0604020202020204" pitchFamily="34" charset="0"/>
+              <a:cs typeface="Arial" panose="020B0604020202020204" pitchFamily="34" charset="0"/>
+            </a:endParaRPr>
+          </a:p>
+          <a:p>
+            <a:r>
+              <a:rPr lang="en-IN" b="1" dirty="0">
+                <a:latin typeface="Arial" panose="020B0604020202020204" pitchFamily="34" charset="0"/>
+                <a:cs typeface="Arial" panose="020B0604020202020204" pitchFamily="34" charset="0"/>
+              </a:rPr>
+              <a:t>How it solves the problem</a:t>
+            </a:r>
+          </a:p>
+          <a:p>
+            <a:pPr marL="457200" indent="-457200">
+              <a:buFont typeface="Arial" panose="020B0604020202020204" pitchFamily="34" charset="0"/>
+              <a:buChar char="•"/>
+            </a:pPr>
+            <a:r>
+              <a:rPr lang="en-IN" dirty="0">
+                <a:latin typeface="Arial" panose="020B0604020202020204" pitchFamily="34" charset="0"/>
+                <a:cs typeface="Arial" panose="020B0604020202020204" pitchFamily="34" charset="0"/>
+              </a:rPr>
+              <a:t>Continuously monitors HVAC, occupancy and environmental conditions </a:t>
+            </a:r>
+          </a:p>
+          <a:p>
+            <a:pPr marL="457200" indent="-457200">
+              <a:buFont typeface="Arial" panose="020B0604020202020204" pitchFamily="34" charset="0"/>
+              <a:buChar char="•"/>
+            </a:pPr>
+            <a:r>
+              <a:rPr lang="en-IN" dirty="0">
+                <a:latin typeface="Arial" panose="020B0604020202020204" pitchFamily="34" charset="0"/>
+                <a:cs typeface="Arial" panose="020B0604020202020204" pitchFamily="34" charset="0"/>
+              </a:rPr>
+              <a:t>Predicts energy demand before wastage occurs </a:t>
+            </a:r>
+          </a:p>
+          <a:p>
+            <a:pPr marL="457200" indent="-457200">
+              <a:buFont typeface="Arial" panose="020B0604020202020204" pitchFamily="34" charset="0"/>
+              <a:buChar char="•"/>
+            </a:pPr>
+            <a:r>
+              <a:rPr lang="en-IN" dirty="0">
+                <a:latin typeface="Arial" panose="020B0604020202020204" pitchFamily="34" charset="0"/>
+                <a:cs typeface="Arial" panose="020B0604020202020204" pitchFamily="34" charset="0"/>
+              </a:rPr>
+              <a:t>Automatically adjusts HVAC setpoints every 15 minutes </a:t>
+            </a:r>
+          </a:p>
+          <a:p>
+            <a:pPr marL="457200" indent="-457200">
+              <a:buFont typeface="Arial" panose="020B0604020202020204" pitchFamily="34" charset="0"/>
+              <a:buChar char="•"/>
+            </a:pPr>
+            <a:r>
+              <a:rPr lang="en-IN" dirty="0">
+                <a:latin typeface="Arial" panose="020B0604020202020204" pitchFamily="34" charset="0"/>
+                <a:cs typeface="Arial" panose="020B0604020202020204" pitchFamily="34" charset="0"/>
+              </a:rPr>
+              <a:t>Maintains occupant comfort while reducing electricity consumption </a:t>
+            </a:r>
+          </a:p>
+          <a:p>
+            <a:pPr marL="457200" indent="-457200">
+              <a:buFont typeface="Arial" panose="020B0604020202020204" pitchFamily="34" charset="0"/>
+              <a:buChar char="•"/>
+            </a:pPr>
+            <a:r>
+              <a:rPr lang="en-IN" dirty="0">
+                <a:latin typeface="Arial" panose="020B0604020202020204" pitchFamily="34" charset="0"/>
+                <a:cs typeface="Arial" panose="020B0604020202020204" pitchFamily="34" charset="0"/>
+              </a:rPr>
+              <a:t>Detects equipment anomalies for predictive maintenance </a:t>
+            </a:r>
+          </a:p>
+          <a:p>
+            <a:pPr marL="457200" indent="-457200">
+              <a:buFont typeface="Arial" panose="020B0604020202020204" pitchFamily="34" charset="0"/>
+              <a:buChar char="•"/>
+            </a:pPr>
+            <a:r>
+              <a:rPr lang="en-IN" dirty="0">
+                <a:latin typeface="Arial" panose="020B0604020202020204" pitchFamily="34" charset="0"/>
+                <a:cs typeface="Arial" panose="020B0604020202020204" pitchFamily="34" charset="0"/>
+              </a:rPr>
+              <a:t>Supports natural language interaction for facility managers </a:t>
+            </a:r>
+          </a:p>
+          <a:p>
+            <a:r>
+              <a:rPr lang="en-IN" b="1" dirty="0">
+                <a:latin typeface="Arial" panose="020B0604020202020204" pitchFamily="34" charset="0"/>
+                <a:cs typeface="Arial" panose="020B0604020202020204" pitchFamily="34" charset="0"/>
+              </a:rPr>
+              <a:t>Innovation &amp; Uniqueness</a:t>
+            </a:r>
+          </a:p>
+          <a:p>
+            <a:pPr marL="457200" indent="-457200">
+              <a:buFont typeface="Arial" panose="020B0604020202020204" pitchFamily="34" charset="0"/>
+              <a:buChar char="•"/>
+            </a:pPr>
+            <a:r>
+              <a:rPr lang="en-IN" dirty="0">
+                <a:latin typeface="Arial" panose="020B0604020202020204" pitchFamily="34" charset="0"/>
+                <a:cs typeface="Arial" panose="020B0604020202020204" pitchFamily="34" charset="0"/>
+              </a:rPr>
+              <a:t>Autonomous AI decision-making instead of fixed rule-based control </a:t>
+            </a:r>
+          </a:p>
+          <a:p>
+            <a:pPr marL="457200" indent="-457200">
+              <a:buFont typeface="Arial" panose="020B0604020202020204" pitchFamily="34" charset="0"/>
+              <a:buChar char="•"/>
+            </a:pPr>
+            <a:r>
+              <a:rPr lang="en-IN" dirty="0">
+                <a:latin typeface="Arial" panose="020B0604020202020204" pitchFamily="34" charset="0"/>
+                <a:cs typeface="Arial" panose="020B0604020202020204" pitchFamily="34" charset="0"/>
+              </a:rPr>
+              <a:t>Multi-agent architecture </a:t>
+            </a:r>
+          </a:p>
+          <a:p>
+            <a:pPr marL="457200" indent="-457200">
+              <a:buFont typeface="Arial" panose="020B0604020202020204" pitchFamily="34" charset="0"/>
+              <a:buChar char="•"/>
+            </a:pPr>
+            <a:r>
+              <a:rPr lang="en-IN" dirty="0">
+                <a:latin typeface="Arial" panose="020B0604020202020204" pitchFamily="34" charset="0"/>
+                <a:cs typeface="Arial" panose="020B0604020202020204" pitchFamily="34" charset="0"/>
+              </a:rPr>
+              <a:t>Digital Twin using </a:t>
+            </a:r>
+            <a:r>
+              <a:rPr lang="en-IN" dirty="0" err="1">
+                <a:latin typeface="Arial" panose="020B0604020202020204" pitchFamily="34" charset="0"/>
+                <a:cs typeface="Arial" panose="020B0604020202020204" pitchFamily="34" charset="0"/>
+              </a:rPr>
+              <a:t>EnergyPlus</a:t>
+            </a:r>
+            <a:r>
+              <a:rPr lang="en-IN" dirty="0">
+                <a:latin typeface="Arial" panose="020B0604020202020204" pitchFamily="34" charset="0"/>
+                <a:cs typeface="Arial" panose="020B0604020202020204" pitchFamily="34" charset="0"/>
+              </a:rPr>
+              <a:t> </a:t>
+            </a:r>
+          </a:p>
+          <a:p>
+            <a:pPr marL="457200" indent="-457200">
+              <a:buFont typeface="Arial" panose="020B0604020202020204" pitchFamily="34" charset="0"/>
+              <a:buChar char="•"/>
+            </a:pPr>
+            <a:r>
+              <a:rPr lang="en-IN" dirty="0">
+                <a:latin typeface="Arial" panose="020B0604020202020204" pitchFamily="34" charset="0"/>
+                <a:cs typeface="Arial" panose="020B0604020202020204" pitchFamily="34" charset="0"/>
+              </a:rPr>
+              <a:t>Hardware-in-the-loop BACnet integration </a:t>
+            </a:r>
+          </a:p>
+          <a:p>
+            <a:pPr marL="457200" indent="-457200">
+              <a:buFont typeface="Arial" panose="020B0604020202020204" pitchFamily="34" charset="0"/>
+              <a:buChar char="•"/>
+            </a:pPr>
+            <a:r>
+              <a:rPr lang="en-IN" dirty="0" err="1">
+                <a:latin typeface="Arial" panose="020B0604020202020204" pitchFamily="34" charset="0"/>
+                <a:cs typeface="Arial" panose="020B0604020202020204" pitchFamily="34" charset="0"/>
+              </a:rPr>
+              <a:t>OpenADR</a:t>
+            </a:r>
+            <a:r>
+              <a:rPr lang="en-IN" dirty="0">
+                <a:latin typeface="Arial" panose="020B0604020202020204" pitchFamily="34" charset="0"/>
+                <a:cs typeface="Arial" panose="020B0604020202020204" pitchFamily="34" charset="0"/>
+              </a:rPr>
+              <a:t> demand response support </a:t>
+            </a:r>
+          </a:p>
+          <a:p>
+            <a:pPr marL="457200" indent="-457200">
+              <a:buFont typeface="Arial" panose="020B0604020202020204" pitchFamily="34" charset="0"/>
+              <a:buChar char="•"/>
+            </a:pPr>
+            <a:r>
+              <a:rPr lang="en-IN" dirty="0">
+                <a:latin typeface="Arial" panose="020B0604020202020204" pitchFamily="34" charset="0"/>
+                <a:cs typeface="Arial" panose="020B0604020202020204" pitchFamily="34" charset="0"/>
+              </a:rPr>
+              <a:t>Self-correcting AI workflow</a:t>
+            </a:r>
+          </a:p>
+          <a:p>
+            <a:pPr marL="342900" indent="-342900" algn="just">
+              <a:buFont typeface="Arial" panose="020B0604020202020204" pitchFamily="34" charset="0"/>
+              <a:buChar char="•"/>
+            </a:pPr>
+            <a:endParaRPr lang="en-US" sz="2800" dirty="0">
+              <a:latin typeface="Arial" panose="020B0604020202020204" pitchFamily="34" charset="0"/>
+              <a:cs typeface="Arial" pitchFamily="34" charset="0"/>
+            </a:endParaRPr>
+          </a:p>
+        </p:txBody>
+      </p:sp>
+      <p:sp>
+        <p:nvSpPr>
+          <p:cNvPr id="6" name="Slide Number Placeholder 5"/>
+          <p:cNvSpPr>
+            <a:spLocks noGrp="1"/>
+          </p:cNvSpPr>
+          <p:nvPr>
+            <p:ph type="sldNum" sz="quarter" idx="12"/>
+          </p:nvPr>
+        </p:nvSpPr>
+        <p:spPr/>
+        <p:txBody>
+          <a:bodyPr/>
+          <a:lstStyle/>
+          <a:p>
+            <a:fld id="{677C3CE7-23F7-4828-823C-E0205DF2CF97}" type="slidenum">
+              <a:rPr lang="en-US" b="1" smtClean="0">
+                <a:solidFill>
+                  <a:schemeClr val="bg1"/>
+                </a:solidFill>
+              </a:rPr>
+              <a:pPr/>
+              <a:t>2</a:t>
+            </a:fld>
+            <a:endParaRPr lang="en-US" b="1" dirty="0">
+              <a:solidFill>
+                <a:schemeClr val="bg1"/>
+              </a:solidFill>
+            </a:endParaRPr>
+          </a:p>
+        </p:txBody>
+      </p:sp>
+      <p:sp>
+        <p:nvSpPr>
+          <p:cNvPr id="7" name="Footer Placeholder 6"/>
+          <p:cNvSpPr>
+            <a:spLocks noGrp="1"/>
+          </p:cNvSpPr>
+          <p:nvPr>
+            <p:ph type="ftr" sz="quarter" idx="11"/>
+          </p:nvPr>
+        </p:nvSpPr>
+        <p:spPr>
+          <a:xfrm>
+            <a:off x="4648200" y="6356353"/>
+            <a:ext cx="3204000" cy="365125"/>
+          </a:xfrm>
+        </p:spPr>
+        <p:txBody>
+          <a:bodyPr/>
+          <a:lstStyle/>
+          <a:p>
+            <a:pPr>
+              <a:defRPr/>
+            </a:pPr>
+            <a:r>
+              <a:rPr lang="en-US">
+                <a:solidFill>
+                  <a:schemeClr val="bg1"/>
+                </a:solidFill>
+              </a:rPr>
+              <a:t>@SIH Idea submission- Template</a:t>
+            </a:r>
+            <a:endParaRPr lang="en-US" dirty="0">
+              <a:solidFill>
+                <a:schemeClr val="bg1"/>
+              </a:solidFill>
+            </a:endParaRPr>
+          </a:p>
+        </p:txBody>
+      </p:sp>
+    </p:spTree>
   </p:cSld>
   <p:clrMapOvr>
     <a:masterClrMapping/>
@@ -6056,7 +5570,7 @@
       </p:grpSpPr>
       <p:sp>
         <p:nvSpPr>
-          <p:cNvPr id="15361" name="Title 1"/>
+          <p:cNvPr id="17409" name="Title 1"/>
           <p:cNvSpPr>
             <a:spLocks noGrp="1"/>
           </p:cNvSpPr>
@@ -6064,140 +5578,19 @@
             <p:ph type="title"/>
           </p:nvPr>
         </p:nvSpPr>
-        <p:spPr>
-          <a:xfrm>
-            <a:off x="182998" y="0"/>
-            <a:ext cx="10972800" cy="1143000"/>
-          </a:xfrm>
-        </p:spPr>
+        <p:spPr/>
         <p:txBody>
           <a:bodyPr/>
           <a:lstStyle/>
           <a:p>
             <a:pPr eaLnBrk="1" hangingPunct="1"/>
-            <a:br>
+            <a:r>
               <a:rPr lang="en-US" sz="3600" b="1" dirty="0">
-                <a:latin typeface="Times New Roman" panose="02020603050405020304" pitchFamily="18" charset="0"/>
+                <a:latin typeface="Arial" panose="020B0604020202020204" pitchFamily="34" charset="0"/>
                 <a:ea typeface="ＭＳ Ｐゴシック" pitchFamily="1" charset="-128"/>
-                <a:cs typeface="Times New Roman" panose="02020603050405020304" pitchFamily="18" charset="0"/>
+                <a:cs typeface="Arial" panose="020B0604020202020204" pitchFamily="34" charset="0"/>
               </a:rPr>
-            </a:br>
-            <a:r>
-              <a:rPr lang="en-US" sz="3600" b="1" dirty="0">
-                <a:latin typeface="Times New Roman" panose="02020603050405020304" pitchFamily="18" charset="0"/>
-                <a:ea typeface="ＭＳ Ｐゴシック" pitchFamily="1" charset="-128"/>
-                <a:cs typeface="Times New Roman" panose="02020603050405020304" pitchFamily="18" charset="0"/>
-              </a:rPr>
-              <a:t>IDEA TITLE</a:t>
-            </a:r>
-          </a:p>
-        </p:txBody>
-      </p:sp>
-      <p:sp>
-        <p:nvSpPr>
-          <p:cNvPr id="15362" name="TextBox 8"/>
-          <p:cNvSpPr txBox="1">
-            <a:spLocks noChangeArrowheads="1"/>
-          </p:cNvSpPr>
-          <p:nvPr/>
-        </p:nvSpPr>
-        <p:spPr bwMode="auto">
-          <a:xfrm>
-            <a:off x="-1" y="2064921"/>
-            <a:ext cx="12191999" cy="2492990"/>
-          </a:xfrm>
-          <a:prstGeom prst="rect">
-            <a:avLst/>
-          </a:prstGeom>
-          <a:noFill/>
-          <a:ln w="9525">
-            <a:noFill/>
-            <a:miter lim="800000"/>
-            <a:headEnd/>
-            <a:tailEnd/>
-          </a:ln>
-        </p:spPr>
-        <p:txBody>
-          <a:bodyPr wrap="square">
-            <a:spAutoFit/>
-          </a:bodyPr>
-          <a:lstStyle/>
-          <a:p>
-            <a:r>
-              <a:rPr lang="en-US" sz="3200" b="1" u="sng" dirty="0">
-                <a:latin typeface="Arial" pitchFamily="34" charset="0"/>
-                <a:cs typeface="Arial" pitchFamily="34" charset="0"/>
-              </a:rPr>
-              <a:t>Proposed Solution (Describe your Idea/Solution/Prototype)</a:t>
-            </a:r>
-            <a:endParaRPr lang="en-US" sz="3200" u="sng" dirty="0">
-              <a:latin typeface="Arial" pitchFamily="34" charset="0"/>
-              <a:cs typeface="Arial" pitchFamily="34" charset="0"/>
-            </a:endParaRPr>
-          </a:p>
-          <a:p>
-            <a:pPr marL="342900" indent="-342900">
-              <a:buFont typeface="Arial" panose="020B0604020202020204" pitchFamily="34" charset="0"/>
-              <a:buChar char="•"/>
-            </a:pPr>
-            <a:endParaRPr lang="en-US" sz="2000" u="sng" dirty="0">
-              <a:solidFill>
-                <a:schemeClr val="tx2"/>
-              </a:solidFill>
-              <a:latin typeface="Arial" pitchFamily="34" charset="0"/>
-              <a:cs typeface="Arial" pitchFamily="34" charset="0"/>
-            </a:endParaRPr>
-          </a:p>
-          <a:p>
-            <a:pPr marL="342900" indent="-342900">
-              <a:buFont typeface="Arial" panose="020B0604020202020204" pitchFamily="34" charset="0"/>
-              <a:buChar char="•"/>
-            </a:pPr>
-            <a:endParaRPr lang="en-US" sz="2000" u="sng" dirty="0">
-              <a:solidFill>
-                <a:schemeClr val="tx2"/>
-              </a:solidFill>
-              <a:latin typeface="Arial" pitchFamily="34" charset="0"/>
-              <a:cs typeface="Arial" pitchFamily="34" charset="0"/>
-            </a:endParaRPr>
-          </a:p>
-          <a:p>
-            <a:pPr marL="342900" indent="-342900" algn="just">
-              <a:buFont typeface="Arial" panose="020B0604020202020204" pitchFamily="34" charset="0"/>
-              <a:buChar char="•"/>
-            </a:pPr>
-            <a:r>
-              <a:rPr lang="en-US" sz="2800" dirty="0">
-                <a:latin typeface="Arial" pitchFamily="34" charset="0"/>
-                <a:cs typeface="Arial" pitchFamily="34" charset="0"/>
-              </a:rPr>
-              <a:t>Detailed explanation of the proposed solution</a:t>
-            </a:r>
-          </a:p>
-          <a:p>
-            <a:pPr marL="342900" indent="-342900" algn="just">
-              <a:buFont typeface="Arial" panose="020B0604020202020204" pitchFamily="34" charset="0"/>
-              <a:buChar char="•"/>
-            </a:pPr>
-            <a:r>
-              <a:rPr lang="en-US" sz="2800" dirty="0">
-                <a:latin typeface="Arial" pitchFamily="34" charset="0"/>
-                <a:cs typeface="Arial" pitchFamily="34" charset="0"/>
-              </a:rPr>
-              <a:t> How it addresses the problem</a:t>
-            </a:r>
-          </a:p>
-          <a:p>
-            <a:pPr marL="342900" indent="-342900" algn="just">
-              <a:buFont typeface="Arial" panose="020B0604020202020204" pitchFamily="34" charset="0"/>
-              <a:buChar char="•"/>
-            </a:pPr>
-            <a:r>
-              <a:rPr lang="en-US" sz="2800" dirty="0">
-                <a:latin typeface="Arial" pitchFamily="34" charset="0"/>
-                <a:cs typeface="Arial" pitchFamily="34" charset="0"/>
-              </a:rPr>
-              <a:t>Innovation and uniqueness of the solution </a:t>
+              <a:t>TECHNICAL APPROACH</a:t>
             </a:r>
           </a:p>
         </p:txBody>
@@ -6218,10 +5611,12 @@
           <a:lstStyle/>
           <a:p>
             <a:fld id="{677C3CE7-23F7-4828-823C-E0205DF2CF97}" type="slidenum">
-              <a:rPr lang="en-US" b="1" smtClean="0">
+              <a:rPr lang="en-US" b="1">
                 <a:solidFill>
                   <a:schemeClr val="bg1"/>
                 </a:solidFill>
+                <a:latin typeface="Arial" panose="020B0604020202020204" pitchFamily="34" charset="0"/>
+                <a:cs typeface="Arial" panose="020B0604020202020204" pitchFamily="34" charset="0"/>
               </a:rPr>
               <a:pPr/>
               <a:t>3</a:t>
@@ -6230,6 +5625,8 @@
               <a:solidFill>
                 <a:schemeClr val="bg1"/>
               </a:solidFill>
+              <a:latin typeface="Arial" panose="020B0604020202020204" pitchFamily="34" charset="0"/>
+              <a:cs typeface="Arial" panose="020B0604020202020204" pitchFamily="34" charset="0"/>
             </a:endParaRPr>
           </a:p>
         </p:txBody>
@@ -6258,21 +5655,381 @@
               <a:defRPr/>
             </a:pPr>
             <a:r>
-              <a:rPr lang="en-US">
+              <a:rPr lang="en-US" dirty="0">
                 <a:solidFill>
                   <a:schemeClr val="bg1"/>
                 </a:solidFill>
+                <a:latin typeface="Arial" panose="020B0604020202020204" pitchFamily="34" charset="0"/>
+                <a:cs typeface="Arial" panose="020B0604020202020204" pitchFamily="34" charset="0"/>
               </a:rPr>
               <a:t>@SIH Idea submission- Template</a:t>
             </a:r>
-            <a:endParaRPr lang="en-US" dirty="0">
-              <a:solidFill>
-                <a:schemeClr val="bg1"/>
-              </a:solidFill>
-            </a:endParaRPr>
-          </a:p>
-        </p:txBody>
-      </p:sp>
+          </a:p>
+        </p:txBody>
+      </p:sp>
+      <p:graphicFrame>
+        <p:nvGraphicFramePr>
+          <p:cNvPr id="4" name="Table 3">
+            <a:extLst>
+              <a:ext uri="{FF2B5EF4-FFF2-40B4-BE49-F238E27FC236}">
+                <a16:creationId xmlns:a16="http://schemas.microsoft.com/office/drawing/2014/main" id="{7EEE4630-1FD2-B3EC-41C5-5CE8C4161863}"/>
+              </a:ext>
+            </a:extLst>
+          </p:cNvPr>
+          <p:cNvGraphicFramePr>
+            <a:graphicFrameLocks noGrp="1"/>
+          </p:cNvGraphicFramePr>
+          <p:nvPr>
+            <p:extLst>
+              <p:ext uri="{D42A27DB-BD31-4B8C-83A1-F6EECF244321}">
+                <p14:modId xmlns:p14="http://schemas.microsoft.com/office/powerpoint/2010/main" val="2532341744"/>
+              </p:ext>
+            </p:extLst>
+          </p:nvPr>
+        </p:nvGraphicFramePr>
+        <p:xfrm>
+          <a:off x="2032000" y="1775460"/>
+          <a:ext cx="8128000" cy="2763520"/>
+        </p:xfrm>
+        <a:graphic>
+          <a:graphicData uri="http://schemas.openxmlformats.org/drawingml/2006/table">
+            <a:tbl>
+              <a:tblPr firstRow="1" bandRow="1">
+                <a:tableStyleId>{5940675A-B579-460E-94D1-54222C63F5DA}</a:tableStyleId>
+              </a:tblPr>
+              <a:tblGrid>
+                <a:gridCol w="4064000">
+                  <a:extLst>
+                    <a:ext uri="{9D8B030D-6E8A-4147-A177-3AD203B41FA5}">
+                      <a16:colId xmlns:a16="http://schemas.microsoft.com/office/drawing/2014/main" val="2729732955"/>
+                    </a:ext>
+                  </a:extLst>
+                </a:gridCol>
+                <a:gridCol w="4064000">
+                  <a:extLst>
+                    <a:ext uri="{9D8B030D-6E8A-4147-A177-3AD203B41FA5}">
+                      <a16:colId xmlns:a16="http://schemas.microsoft.com/office/drawing/2014/main" val="1924814"/>
+                    </a:ext>
+                  </a:extLst>
+                </a:gridCol>
+              </a:tblGrid>
+              <a:tr h="370840">
+                <a:tc>
+                  <a:txBody>
+                    <a:bodyPr/>
+                    <a:lstStyle/>
+                    <a:p>
+                      <a:pPr algn="l"/>
+                      <a:r>
+                        <a:rPr lang="en-IN" sz="1800" b="1" dirty="0"/>
+                        <a:t>Programming Language</a:t>
+                      </a:r>
+                      <a:endParaRPr lang="en-IN" sz="1800" dirty="0"/>
+                    </a:p>
+                  </a:txBody>
+                  <a:tcPr/>
+                </a:tc>
+                <a:tc>
+                  <a:txBody>
+                    <a:bodyPr/>
+                    <a:lstStyle/>
+                    <a:p>
+                      <a:pPr algn="l"/>
+                      <a:r>
+                        <a:rPr lang="en-IN" sz="1800" dirty="0"/>
+                        <a:t>Python 3.11</a:t>
+                      </a:r>
+                      <a:endParaRPr lang="en-IN" dirty="0"/>
+                    </a:p>
+                  </a:txBody>
+                  <a:tcPr/>
+                </a:tc>
+                <a:extLst>
+                  <a:ext uri="{0D108BD9-81ED-4DB2-BD59-A6C34878D82A}">
+                    <a16:rowId xmlns:a16="http://schemas.microsoft.com/office/drawing/2014/main" val="772750725"/>
+                  </a:ext>
+                </a:extLst>
+              </a:tr>
+              <a:tr h="370840">
+                <a:tc>
+                  <a:txBody>
+                    <a:bodyPr/>
+                    <a:lstStyle/>
+                    <a:p>
+                      <a:pPr algn="l"/>
+                      <a:r>
+                        <a:rPr lang="en-IN" sz="1800" b="1" dirty="0"/>
+                        <a:t>AI</a:t>
+                      </a:r>
+                      <a:endParaRPr lang="en-IN" dirty="0"/>
+                    </a:p>
+                  </a:txBody>
+                  <a:tcPr/>
+                </a:tc>
+                <a:tc>
+                  <a:txBody>
+                    <a:bodyPr/>
+                    <a:lstStyle/>
+                    <a:p>
+                      <a:pPr marL="0" marR="0" lvl="0" indent="0" algn="l" defTabSz="457200" rtl="0" eaLnBrk="1" fontAlgn="auto" latinLnBrk="0" hangingPunct="1">
+                        <a:lnSpc>
+                          <a:spcPct val="100000"/>
+                        </a:lnSpc>
+                        <a:spcBef>
+                          <a:spcPts val="0"/>
+                        </a:spcBef>
+                        <a:spcAft>
+                          <a:spcPts val="0"/>
+                        </a:spcAft>
+                        <a:buClrTx/>
+                        <a:buSzTx/>
+                        <a:buFontTx/>
+                        <a:buNone/>
+                        <a:tabLst/>
+                        <a:defRPr/>
+                      </a:pPr>
+                      <a:r>
+                        <a:rPr lang="en-IN" sz="1800" dirty="0"/>
+                        <a:t>Qwen2.5 7B Instruct Model using</a:t>
+                      </a:r>
+                    </a:p>
+                    <a:p>
+                      <a:pPr algn="l"/>
+                      <a:r>
+                        <a:rPr lang="en-IN" sz="1800" dirty="0" err="1"/>
+                        <a:t>Ollama</a:t>
+                      </a:r>
+                      <a:endParaRPr lang="en-IN" dirty="0"/>
+                    </a:p>
+                  </a:txBody>
+                  <a:tcPr/>
+                </a:tc>
+                <a:extLst>
+                  <a:ext uri="{0D108BD9-81ED-4DB2-BD59-A6C34878D82A}">
+                    <a16:rowId xmlns:a16="http://schemas.microsoft.com/office/drawing/2014/main" val="4072646188"/>
+                  </a:ext>
+                </a:extLst>
+              </a:tr>
+              <a:tr h="370840">
+                <a:tc>
+                  <a:txBody>
+                    <a:bodyPr/>
+                    <a:lstStyle/>
+                    <a:p>
+                      <a:pPr algn="l"/>
+                      <a:r>
+                        <a:rPr lang="en-IN" sz="1800" b="1" dirty="0"/>
+                        <a:t>Simulation</a:t>
+                      </a:r>
+                      <a:endParaRPr lang="en-IN" dirty="0"/>
+                    </a:p>
+                  </a:txBody>
+                  <a:tcPr/>
+                </a:tc>
+                <a:tc>
+                  <a:txBody>
+                    <a:bodyPr/>
+                    <a:lstStyle/>
+                    <a:p>
+                      <a:pPr marL="0" marR="0" lvl="0" indent="0" algn="l" defTabSz="457200" rtl="0" eaLnBrk="1" fontAlgn="auto" latinLnBrk="0" hangingPunct="1">
+                        <a:lnSpc>
+                          <a:spcPct val="100000"/>
+                        </a:lnSpc>
+                        <a:spcBef>
+                          <a:spcPts val="0"/>
+                        </a:spcBef>
+                        <a:spcAft>
+                          <a:spcPts val="0"/>
+                        </a:spcAft>
+                        <a:buClrTx/>
+                        <a:buSzTx/>
+                        <a:buFontTx/>
+                        <a:buNone/>
+                        <a:tabLst/>
+                        <a:defRPr/>
+                      </a:pPr>
+                      <a:r>
+                        <a:rPr lang="en-IN" sz="1800" dirty="0" err="1"/>
+                        <a:t>EnergyPlus</a:t>
+                      </a:r>
+                      <a:r>
+                        <a:rPr lang="en-IN" sz="1800" dirty="0"/>
+                        <a:t> 26.1 </a:t>
+                      </a:r>
+                      <a:endParaRPr lang="en-IN" dirty="0"/>
+                    </a:p>
+                  </a:txBody>
+                  <a:tcPr/>
+                </a:tc>
+                <a:extLst>
+                  <a:ext uri="{0D108BD9-81ED-4DB2-BD59-A6C34878D82A}">
+                    <a16:rowId xmlns:a16="http://schemas.microsoft.com/office/drawing/2014/main" val="4193384300"/>
+                  </a:ext>
+                </a:extLst>
+              </a:tr>
+              <a:tr h="370840">
+                <a:tc>
+                  <a:txBody>
+                    <a:bodyPr/>
+                    <a:lstStyle/>
+                    <a:p>
+                      <a:pPr algn="l"/>
+                      <a:r>
+                        <a:rPr lang="en-IN" sz="1800" b="1" dirty="0"/>
+                        <a:t>Protocols</a:t>
+                      </a:r>
+                      <a:endParaRPr lang="en-IN" dirty="0"/>
+                    </a:p>
+                  </a:txBody>
+                  <a:tcPr/>
+                </a:tc>
+                <a:tc>
+                  <a:txBody>
+                    <a:bodyPr/>
+                    <a:lstStyle/>
+                    <a:p>
+                      <a:pPr algn="l"/>
+                      <a:r>
+                        <a:rPr lang="en-IN" sz="1800" dirty="0"/>
+                        <a:t>BACnet/IP, </a:t>
+                      </a:r>
+                      <a:r>
+                        <a:rPr lang="en-IN" sz="1800" dirty="0" err="1"/>
+                        <a:t>OpenADR</a:t>
+                      </a:r>
+                      <a:r>
+                        <a:rPr lang="en-IN" sz="1800" dirty="0"/>
+                        <a:t> 2.0b </a:t>
+                      </a:r>
+                      <a:endParaRPr lang="en-IN" dirty="0"/>
+                    </a:p>
+                  </a:txBody>
+                  <a:tcPr/>
+                </a:tc>
+                <a:extLst>
+                  <a:ext uri="{0D108BD9-81ED-4DB2-BD59-A6C34878D82A}">
+                    <a16:rowId xmlns:a16="http://schemas.microsoft.com/office/drawing/2014/main" val="3867614415"/>
+                  </a:ext>
+                </a:extLst>
+              </a:tr>
+              <a:tr h="370840">
+                <a:tc>
+                  <a:txBody>
+                    <a:bodyPr/>
+                    <a:lstStyle/>
+                    <a:p>
+                      <a:pPr algn="l"/>
+                      <a:r>
+                        <a:rPr lang="en-IN" sz="1800" b="1" dirty="0"/>
+                        <a:t>Dashboard</a:t>
+                      </a:r>
+                      <a:endParaRPr lang="en-IN" dirty="0"/>
+                    </a:p>
+                  </a:txBody>
+                  <a:tcPr/>
+                </a:tc>
+                <a:tc>
+                  <a:txBody>
+                    <a:bodyPr/>
+                    <a:lstStyle/>
+                    <a:p>
+                      <a:pPr algn="l"/>
+                      <a:r>
+                        <a:rPr lang="en-IN" sz="1800" dirty="0" err="1"/>
+                        <a:t>Plotly</a:t>
+                      </a:r>
+                      <a:r>
+                        <a:rPr lang="en-IN" sz="1800" dirty="0"/>
+                        <a:t> Dash </a:t>
+                      </a:r>
+                      <a:endParaRPr lang="en-IN" dirty="0"/>
+                    </a:p>
+                  </a:txBody>
+                  <a:tcPr/>
+                </a:tc>
+                <a:extLst>
+                  <a:ext uri="{0D108BD9-81ED-4DB2-BD59-A6C34878D82A}">
+                    <a16:rowId xmlns:a16="http://schemas.microsoft.com/office/drawing/2014/main" val="3209255779"/>
+                  </a:ext>
+                </a:extLst>
+              </a:tr>
+              <a:tr h="370840">
+                <a:tc>
+                  <a:txBody>
+                    <a:bodyPr/>
+                    <a:lstStyle/>
+                    <a:p>
+                      <a:pPr marL="0" marR="0" lvl="0" indent="0" algn="l" defTabSz="457200" rtl="0" eaLnBrk="1" fontAlgn="auto" latinLnBrk="0" hangingPunct="1">
+                        <a:lnSpc>
+                          <a:spcPct val="100000"/>
+                        </a:lnSpc>
+                        <a:spcBef>
+                          <a:spcPts val="0"/>
+                        </a:spcBef>
+                        <a:spcAft>
+                          <a:spcPts val="0"/>
+                        </a:spcAft>
+                        <a:buClrTx/>
+                        <a:buSzTx/>
+                        <a:buFontTx/>
+                        <a:buNone/>
+                        <a:tabLst/>
+                        <a:defRPr/>
+                      </a:pPr>
+                      <a:r>
+                        <a:rPr lang="en-IN" sz="1800" b="1" dirty="0"/>
+                        <a:t>Architecture</a:t>
+                      </a:r>
+                      <a:endParaRPr lang="en-IN" dirty="0"/>
+                    </a:p>
+                    <a:p>
+                      <a:pPr algn="l"/>
+                      <a:endParaRPr lang="en-IN" dirty="0"/>
+                    </a:p>
+                  </a:txBody>
+                  <a:tcPr/>
+                </a:tc>
+                <a:tc>
+                  <a:txBody>
+                    <a:bodyPr/>
+                    <a:lstStyle/>
+                    <a:p>
+                      <a:pPr marL="0" marR="0" lvl="0" indent="0" algn="l" defTabSz="457200" rtl="0" eaLnBrk="1" fontAlgn="auto" latinLnBrk="0" hangingPunct="1">
+                        <a:lnSpc>
+                          <a:spcPct val="100000"/>
+                        </a:lnSpc>
+                        <a:spcBef>
+                          <a:spcPts val="0"/>
+                        </a:spcBef>
+                        <a:spcAft>
+                          <a:spcPts val="0"/>
+                        </a:spcAft>
+                        <a:buClrTx/>
+                        <a:buSzTx/>
+                        <a:buFontTx/>
+                        <a:buNone/>
+                        <a:tabLst/>
+                        <a:defRPr/>
+                      </a:pPr>
+                      <a:r>
+                        <a:rPr lang="en-IN" sz="1800" dirty="0"/>
+                        <a:t>Multi-Agent Swarm, MCP (Model Context Protocol)</a:t>
+                      </a:r>
+                      <a:endParaRPr lang="en-IN" dirty="0"/>
+                    </a:p>
+                  </a:txBody>
+                  <a:tcPr/>
+                </a:tc>
+                <a:extLst>
+                  <a:ext uri="{0D108BD9-81ED-4DB2-BD59-A6C34878D82A}">
+                    <a16:rowId xmlns:a16="http://schemas.microsoft.com/office/drawing/2014/main" val="1358930795"/>
+                  </a:ext>
+                </a:extLst>
+              </a:tr>
+            </a:tbl>
+          </a:graphicData>
+        </a:graphic>
+      </p:graphicFrame>
     </p:spTree>
   </p:cSld>
   <p:clrMapOvr>
@@ -6320,7 +6077,7 @@
                 <a:ea typeface="ＭＳ Ｐゴシック" pitchFamily="1" charset="-128"/>
                 <a:cs typeface="Times New Roman" panose="02020603050405020304" pitchFamily="18" charset="0"/>
               </a:rPr>
-              <a:t>TECHNICAL APPROACH</a:t>
+              <a:t>FEASIBILITY AND VIABILITY</a:t>
             </a:r>
           </a:p>
         </p:txBody>
@@ -6335,8 +6092,8 @@
         </p:nvSpPr>
         <p:spPr bwMode="auto">
           <a:xfrm>
-            <a:off x="609600" y="2533653"/>
-            <a:ext cx="9385300" cy="1815882"/>
+            <a:off x="1379613" y="1095375"/>
+            <a:ext cx="4391983" cy="4524315"/>
           </a:xfrm>
           <a:prstGeom prst="rect">
             <a:avLst/>
@@ -6355,30 +6112,118 @@
           </a:bodyPr>
           <a:lstStyle/>
           <a:p>
-            <a:pPr marL="342900" indent="-342900" algn="just">
+            <a:r>
+              <a:rPr lang="en-IN" b="1" dirty="0"/>
+              <a:t>Feasibility 							</a:t>
+            </a:r>
+          </a:p>
+          <a:p>
+            <a:pPr marL="285750" indent="-285750">
               <a:buFont typeface="Arial" panose="020B0604020202020204" pitchFamily="34" charset="0"/>
               <a:buChar char="•"/>
             </a:pPr>
             <a:r>
-              <a:rPr lang="en-US" sz="2800" dirty="0">
-                <a:latin typeface="Arial" pitchFamily="34" charset="0"/>
-                <a:cs typeface="Arial" pitchFamily="34" charset="0"/>
-              </a:rPr>
-              <a:t>Technologies to be used (e.g. programming languages, frameworks, hardware)</a:t>
-            </a:r>
-          </a:p>
-          <a:p>
-            <a:pPr marL="342900" indent="-342900" algn="just">
+              <a:rPr lang="en-IN" dirty="0"/>
+              <a:t>Uses open-source AI models </a:t>
+            </a:r>
+          </a:p>
+          <a:p>
+            <a:pPr marL="285750" indent="-285750">
               <a:buFont typeface="Arial" panose="020B0604020202020204" pitchFamily="34" charset="0"/>
               <a:buChar char="•"/>
             </a:pPr>
             <a:r>
-              <a:rPr lang="en-US" sz="2800" dirty="0">
-                <a:latin typeface="Arial" pitchFamily="34" charset="0"/>
-                <a:cs typeface="Arial" pitchFamily="34" charset="0"/>
-              </a:rPr>
-              <a:t>Methodology and process for implementation (Flow Charts/Images/ working prototype)</a:t>
-            </a:r>
+              <a:rPr lang="en-IN" dirty="0"/>
+              <a:t>Compatible with existing Honeywell BMS </a:t>
+            </a:r>
+          </a:p>
+          <a:p>
+            <a:pPr marL="285750" indent="-285750">
+              <a:buFont typeface="Arial" panose="020B0604020202020204" pitchFamily="34" charset="0"/>
+              <a:buChar char="•"/>
+            </a:pPr>
+            <a:r>
+              <a:rPr lang="en-IN" dirty="0"/>
+              <a:t>Works with standard BACnet devices </a:t>
+            </a:r>
+          </a:p>
+          <a:p>
+            <a:pPr marL="285750" indent="-285750">
+              <a:buFont typeface="Arial" panose="020B0604020202020204" pitchFamily="34" charset="0"/>
+              <a:buChar char="•"/>
+            </a:pPr>
+            <a:r>
+              <a:rPr lang="en-IN" dirty="0"/>
+              <a:t>Easily scalable across commercial buildings </a:t>
+            </a:r>
+          </a:p>
+          <a:p>
+            <a:pPr marL="285750" indent="-285750">
+              <a:buFont typeface="Arial" panose="020B0604020202020204" pitchFamily="34" charset="0"/>
+              <a:buChar char="•"/>
+            </a:pPr>
+            <a:r>
+              <a:rPr lang="en-IN" dirty="0"/>
+              <a:t>Cloud or on-premise deployment</a:t>
+            </a:r>
+          </a:p>
+          <a:p>
+            <a:endParaRPr lang="en-IN" dirty="0"/>
+          </a:p>
+          <a:p>
+            <a:endParaRPr lang="en-IN" dirty="0"/>
+          </a:p>
+          <a:p>
+            <a:r>
+              <a:rPr lang="en-IN" b="1" dirty="0"/>
+              <a:t>Challenges</a:t>
+            </a:r>
+          </a:p>
+          <a:p>
+            <a:pPr marL="285750" indent="-285750">
+              <a:buFont typeface="Arial" panose="020B0604020202020204" pitchFamily="34" charset="0"/>
+              <a:buChar char="•"/>
+            </a:pPr>
+            <a:r>
+              <a:rPr lang="en-IN" dirty="0"/>
+              <a:t>Sensor data quality </a:t>
+            </a:r>
+          </a:p>
+          <a:p>
+            <a:pPr marL="285750" indent="-285750">
+              <a:buFont typeface="Arial" panose="020B0604020202020204" pitchFamily="34" charset="0"/>
+              <a:buChar char="•"/>
+            </a:pPr>
+            <a:r>
+              <a:rPr lang="en-IN" dirty="0"/>
+              <a:t>Real-time communication delays </a:t>
+            </a:r>
+          </a:p>
+          <a:p>
+            <a:pPr marL="285750" indent="-285750">
+              <a:buFont typeface="Arial" panose="020B0604020202020204" pitchFamily="34" charset="0"/>
+              <a:buChar char="•"/>
+            </a:pPr>
+            <a:r>
+              <a:rPr lang="en-IN" dirty="0"/>
+              <a:t>LLM safety in industrial control </a:t>
+            </a:r>
+          </a:p>
+          <a:p>
+            <a:pPr marL="285750" indent="-285750">
+              <a:buFont typeface="Arial" panose="020B0604020202020204" pitchFamily="34" charset="0"/>
+              <a:buChar char="•"/>
+            </a:pPr>
+            <a:r>
+              <a:rPr lang="en-IN" dirty="0"/>
+              <a:t>Hardware compatibility</a:t>
+            </a:r>
+          </a:p>
+          <a:p>
+            <a:endParaRPr lang="en-IN" dirty="0"/>
+          </a:p>
+          <a:p>
+            <a:endParaRPr lang="en-IN" dirty="0"/>
           </a:p>
         </p:txBody>
       </p:sp>
@@ -6397,19 +6242,70 @@
           <a:bodyPr/>
           <a:lstStyle/>
           <a:p>
+            <a:pPr marL="0" marR="0" lvl="0" indent="0" algn="r" defTabSz="457200" rtl="0" eaLnBrk="1" fontAlgn="base" latinLnBrk="0" hangingPunct="1">
+              <a:lnSpc>
+                <a:spcPct val="100000"/>
+              </a:lnSpc>
+              <a:spcBef>
+                <a:spcPct val="0"/>
+              </a:spcBef>
+              <a:spcAft>
+                <a:spcPct val="0"/>
+              </a:spcAft>
+              <a:buClrTx/>
+              <a:buSzTx/>
+              <a:buFontTx/>
+              <a:buNone/>
+              <a:tabLst/>
+              <a:defRPr/>
+            </a:pPr>
             <a:fld id="{677C3CE7-23F7-4828-823C-E0205DF2CF97}" type="slidenum">
-              <a:rPr lang="en-US" b="1">
+              <a:rPr kumimoji="0" lang="en-US" sz="1200" b="1" i="0" u="none" strike="noStrike" kern="1200" cap="none" spc="0" normalizeH="0" baseline="0" noProof="0">
+                <a:ln>
+                  <a:noFill/>
+                </a:ln>
                 <a:solidFill>
-                  <a:schemeClr val="bg1"/>
+                  <a:prstClr val="white"/>
                 </a:solidFill>
+                <a:effectLst/>
+                <a:uLnTx/>
+                <a:uFillTx/>
+                <a:latin typeface="TradeGothic" pitchFamily="1" charset="0"/>
+                <a:ea typeface="ＭＳ Ｐゴシック" pitchFamily="1" charset="-128"/>
+                <a:cs typeface="+mn-cs"/>
               </a:rPr>
-              <a:pPr/>
+              <a:pPr marL="0" marR="0" lvl="0" indent="0" algn="r" defTabSz="457200" rtl="0" eaLnBrk="1" fontAlgn="base" latinLnBrk="0" hangingPunct="1">
+                <a:lnSpc>
+                  <a:spcPct val="100000"/>
+                </a:lnSpc>
+                <a:spcBef>
+                  <a:spcPct val="0"/>
+                </a:spcBef>
+                <a:spcAft>
+                  <a:spcPct val="0"/>
+                </a:spcAft>
+                <a:buClrTx/>
+                <a:buSzTx/>
+                <a:buFontTx/>
+                <a:buNone/>
+                <a:tabLst/>
+                <a:defRPr/>
+              </a:pPr>
               <a:t>4</a:t>
             </a:fld>
-            <a:endParaRPr lang="en-US" b="1" dirty="0">
+            <a:endParaRPr kumimoji="0" lang="en-US" sz="1200" b="1" i="0" u="none" strike="noStrike" kern="1200" cap="none" spc="0" normalizeH="0" baseline="0" noProof="0" dirty="0">
+              <a:ln>
+                <a:noFill/>
+              </a:ln>
               <a:solidFill>
-                <a:schemeClr val="bg1"/>
+                <a:prstClr val="white"/>
               </a:solidFill>
+              <a:effectLst/>
+              <a:uLnTx/>
+              <a:uFillTx/>
+              <a:latin typeface="TradeGothic" pitchFamily="1" charset="0"/>
+              <a:ea typeface="ＭＳ Ｐゴシック" pitchFamily="1" charset="-128"/>
+              <a:cs typeface="+mn-cs"/>
             </a:endParaRPr>
           </a:p>
         </p:txBody>
@@ -6434,26 +6330,222 @@
           <a:bodyPr/>
           <a:lstStyle/>
           <a:p>
-            <a:pPr>
+            <a:pPr marL="0" marR="0" lvl="0" indent="0" algn="ctr" defTabSz="457200" rtl="0" eaLnBrk="1" fontAlgn="auto" latinLnBrk="0" hangingPunct="1">
+              <a:lnSpc>
+                <a:spcPct val="100000"/>
+              </a:lnSpc>
+              <a:spcBef>
+                <a:spcPts val="0"/>
+              </a:spcBef>
+              <a:spcAft>
+                <a:spcPts val="0"/>
+              </a:spcAft>
+              <a:buClrTx/>
+              <a:buSzTx/>
+              <a:buFontTx/>
+              <a:buNone/>
+              <a:tabLst/>
               <a:defRPr/>
             </a:pPr>
             <a:r>
-              <a:rPr lang="en-US">
+              <a:rPr kumimoji="0" lang="en-US" sz="1200" b="0" i="0" u="none" strike="noStrike" kern="1200" cap="none" spc="0" normalizeH="0" baseline="0" noProof="0">
+                <a:ln>
+                  <a:noFill/>
+                </a:ln>
                 <a:solidFill>
-                  <a:schemeClr val="bg1"/>
+                  <a:prstClr val="white"/>
                 </a:solidFill>
+                <a:effectLst/>
+                <a:uLnTx/>
+                <a:uFillTx/>
+                <a:latin typeface="TradeGothic"/>
+                <a:ea typeface="+mn-ea"/>
+                <a:cs typeface="+mn-cs"/>
               </a:rPr>
               <a:t>@SIH Idea submission- Template</a:t>
             </a:r>
-            <a:endParaRPr lang="en-US" dirty="0">
+            <a:endParaRPr kumimoji="0" lang="en-US" sz="1200" b="0" i="0" u="none" strike="noStrike" kern="1200" cap="none" spc="0" normalizeH="0" baseline="0" noProof="0" dirty="0">
+              <a:ln>
+                <a:noFill/>
+              </a:ln>
               <a:solidFill>
-                <a:schemeClr val="bg1"/>
+                <a:prstClr val="white"/>
               </a:solidFill>
+              <a:effectLst/>
+              <a:uLnTx/>
+              <a:uFillTx/>
+              <a:latin typeface="TradeGothic"/>
+              <a:ea typeface="+mn-ea"/>
+              <a:cs typeface="+mn-cs"/>
             </a:endParaRPr>
           </a:p>
         </p:txBody>
       </p:sp>
+      <p:sp>
+        <p:nvSpPr>
+          <p:cNvPr id="3" name="TextBox 8">
+            <a:extLst>
+              <a:ext uri="{FF2B5EF4-FFF2-40B4-BE49-F238E27FC236}">
+                <a16:creationId xmlns:a16="http://schemas.microsoft.com/office/drawing/2014/main" id="{DDA1103C-202A-1F88-3C00-AA8482157A72}"/>
+              </a:ext>
+            </a:extLst>
+          </p:cNvPr>
+          <p:cNvSpPr txBox="1">
+            <a:spLocks noChangeArrowheads="1"/>
+          </p:cNvSpPr>
+          <p:nvPr/>
+        </p:nvSpPr>
+        <p:spPr bwMode="auto">
+          <a:xfrm>
+            <a:off x="6541608" y="1097042"/>
+            <a:ext cx="4391983" cy="4247317"/>
+          </a:xfrm>
+          <a:prstGeom prst="rect">
+            <a:avLst/>
+          </a:prstGeom>
+          <a:noFill/>
+          <a:ln w="9525">
+            <a:noFill/>
+            <a:miter lim="800000"/>
+            <a:headEnd/>
+            <a:tailEnd/>
+          </a:ln>
+        </p:spPr>
+        <p:txBody>
+          <a:bodyPr wrap="square">
+            <a:spAutoFit/>
+          </a:bodyPr>
+          <a:lstStyle/>
+          <a:p>
+            <a:r>
+              <a:rPr lang="en-IN" b="1" dirty="0"/>
+              <a:t>Expected Benefits</a:t>
+            </a:r>
+          </a:p>
+          <a:p>
+            <a:pPr marL="285750" indent="-285750">
+              <a:buFont typeface="Arial" panose="020B0604020202020204" pitchFamily="34" charset="0"/>
+              <a:buChar char="•"/>
+            </a:pPr>
+            <a:r>
+              <a:rPr lang="en-IN" dirty="0"/>
+              <a:t>Around </a:t>
+            </a:r>
+            <a:r>
+              <a:rPr lang="en-IN" b="1" dirty="0"/>
+              <a:t>24% energy reduction</a:t>
+            </a:r>
+            <a:r>
+              <a:rPr lang="en-IN" dirty="0"/>
+              <a:t> </a:t>
+            </a:r>
+          </a:p>
+          <a:p>
+            <a:pPr marL="285750" indent="-285750">
+              <a:buFont typeface="Arial" panose="020B0604020202020204" pitchFamily="34" charset="0"/>
+              <a:buChar char="•"/>
+            </a:pPr>
+            <a:r>
+              <a:rPr lang="en-IN" dirty="0"/>
+              <a:t>Improved occupant comfort </a:t>
+            </a:r>
+          </a:p>
+          <a:p>
+            <a:pPr marL="285750" indent="-285750">
+              <a:buFont typeface="Arial" panose="020B0604020202020204" pitchFamily="34" charset="0"/>
+              <a:buChar char="•"/>
+            </a:pPr>
+            <a:r>
+              <a:rPr lang="en-IN" dirty="0"/>
+              <a:t>Lower operational costs </a:t>
+            </a:r>
+          </a:p>
+          <a:p>
+            <a:pPr marL="285750" indent="-285750">
+              <a:buFont typeface="Arial" panose="020B0604020202020204" pitchFamily="34" charset="0"/>
+              <a:buChar char="•"/>
+            </a:pPr>
+            <a:r>
+              <a:rPr lang="en-IN" dirty="0"/>
+              <a:t>Reduced carbon emissions </a:t>
+            </a:r>
+          </a:p>
+          <a:p>
+            <a:pPr marL="285750" indent="-285750">
+              <a:buFont typeface="Arial" panose="020B0604020202020204" pitchFamily="34" charset="0"/>
+              <a:buChar char="•"/>
+            </a:pPr>
+            <a:r>
+              <a:rPr lang="en-IN" dirty="0"/>
+              <a:t>Predictive maintenance support</a:t>
+            </a:r>
+          </a:p>
+          <a:p>
+            <a:endParaRPr lang="en-IN" dirty="0"/>
+          </a:p>
+          <a:p>
+            <a:endParaRPr lang="en-IN" dirty="0"/>
+          </a:p>
+          <a:p>
+            <a:endParaRPr lang="en-IN" dirty="0"/>
+          </a:p>
+          <a:p>
+            <a:r>
+              <a:rPr lang="en-IN" b="1" dirty="0"/>
+              <a:t>Mitigation</a:t>
+            </a:r>
+          </a:p>
+          <a:p>
+            <a:pPr marL="285750" indent="-285750">
+              <a:buFont typeface="Arial" panose="020B0604020202020204" pitchFamily="34" charset="0"/>
+              <a:buChar char="•"/>
+            </a:pPr>
+            <a:r>
+              <a:rPr lang="en-IN" dirty="0"/>
+              <a:t>Safety guardrails </a:t>
+            </a:r>
+          </a:p>
+          <a:p>
+            <a:pPr marL="285750" indent="-285750">
+              <a:buFont typeface="Arial" panose="020B0604020202020204" pitchFamily="34" charset="0"/>
+              <a:buChar char="•"/>
+            </a:pPr>
+            <a:r>
+              <a:rPr lang="en-IN" dirty="0"/>
+              <a:t>Rule-based validation </a:t>
+            </a:r>
+          </a:p>
+          <a:p>
+            <a:pPr marL="285750" indent="-285750">
+              <a:buFont typeface="Arial" panose="020B0604020202020204" pitchFamily="34" charset="0"/>
+              <a:buChar char="•"/>
+            </a:pPr>
+            <a:r>
+              <a:rPr lang="en-IN" dirty="0"/>
+              <a:t>Human override capability </a:t>
+            </a:r>
+          </a:p>
+          <a:p>
+            <a:pPr marL="285750" indent="-285750">
+              <a:buFont typeface="Arial" panose="020B0604020202020204" pitchFamily="34" charset="0"/>
+              <a:buChar char="•"/>
+            </a:pPr>
+            <a:r>
+              <a:rPr lang="en-IN" dirty="0"/>
+              <a:t>Fail-safe default HVAC settings</a:t>
+            </a:r>
+          </a:p>
+          <a:p>
+            <a:endParaRPr lang="en-IN" dirty="0"/>
+          </a:p>
+        </p:txBody>
+      </p:sp>
     </p:spTree>
+    <p:extLst>
+      <p:ext uri="{BB962C8B-B14F-4D97-AF65-F5344CB8AC3E}">
+        <p14:creationId xmlns:p14="http://schemas.microsoft.com/office/powerpoint/2010/main" val="3753387913"/>
+      </p:ext>
+    </p:extLst>
   </p:cSld>
   <p:clrMapOvr>
     <a:masterClrMapping/>
@@ -6466,7 +6558,13 @@
   <p:cSld>
     <p:spTree>
       <p:nvGrpSpPr>
-        <p:cNvPr id="1" name=""/>
+        <p:cNvPr id="1" name="">
+          <a:extLst>
+            <a:ext uri="{FF2B5EF4-FFF2-40B4-BE49-F238E27FC236}">
+              <a16:creationId xmlns:a16="http://schemas.microsoft.com/office/drawing/2014/main" id="{48B09052-50AE-B3C2-6A1C-5CFF37D94A7E}"/>
+            </a:ext>
+          </a:extLst>
+        </p:cNvPr>
         <p:cNvGrpSpPr/>
         <p:nvPr/>
       </p:nvGrpSpPr>
@@ -6478,9 +6576,46 @@
           <a:chExt cx="0" cy="0"/>
         </a:xfrm>
       </p:grpSpPr>
-      <p:sp>
-        <p:nvSpPr>
-          <p:cNvPr id="17409" name="Title 1"/>
+      <p:pic>
+        <p:nvPicPr>
+          <p:cNvPr id="19" name="Picture 18">
+            <a:extLst>
+              <a:ext uri="{FF2B5EF4-FFF2-40B4-BE49-F238E27FC236}">
+                <a16:creationId xmlns:a16="http://schemas.microsoft.com/office/drawing/2014/main" id="{E5C93C1C-954A-3823-9DC4-684C3675752A}"/>
+              </a:ext>
+            </a:extLst>
+          </p:cNvPr>
+          <p:cNvPicPr>
+            <a:picLocks noChangeAspect="1"/>
+          </p:cNvPicPr>
+          <p:nvPr/>
+        </p:nvPicPr>
+        <p:blipFill>
+          <a:blip r:embed="rId3"/>
+          <a:srcRect r="46693"/>
+          <a:stretch>
+            <a:fillRect/>
+          </a:stretch>
+        </p:blipFill>
+        <p:spPr>
+          <a:xfrm>
+            <a:off x="1939069" y="190902"/>
+            <a:ext cx="8622262" cy="3238098"/>
+          </a:xfrm>
+          <a:prstGeom prst="rect">
+            <a:avLst/>
+          </a:prstGeom>
+        </p:spPr>
+      </p:pic>
+      <p:sp>
+        <p:nvSpPr>
+          <p:cNvPr id="17409" name="Title 1">
+            <a:extLst>
+              <a:ext uri="{FF2B5EF4-FFF2-40B4-BE49-F238E27FC236}">
+                <a16:creationId xmlns:a16="http://schemas.microsoft.com/office/drawing/2014/main" id="{5E03BF1A-7989-5C44-934B-D93E149184A6}"/>
+              </a:ext>
+            </a:extLst>
+          </p:cNvPr>
           <p:cNvSpPr>
             <a:spLocks noGrp="1"/>
           </p:cNvSpPr>
@@ -6500,184 +6635,20 @@
                 <a:ea typeface="ＭＳ Ｐゴシック" pitchFamily="1" charset="-128"/>
                 <a:cs typeface="Times New Roman" panose="02020603050405020304" pitchFamily="18" charset="0"/>
               </a:rPr>
-              <a:t>FEASIBILITY AND VIABILITY</a:t>
-            </a:r>
-          </a:p>
-        </p:txBody>
-      </p:sp>
-      <p:sp>
-        <p:nvSpPr>
-          <p:cNvPr id="17410" name="TextBox 8"/>
-          <p:cNvSpPr txBox="1">
-            <a:spLocks noChangeArrowheads="1"/>
-          </p:cNvSpPr>
-          <p:nvPr/>
-        </p:nvSpPr>
-        <p:spPr bwMode="auto">
-          <a:xfrm>
-            <a:off x="609600" y="2533653"/>
-            <a:ext cx="9385300" cy="1384995"/>
-          </a:xfrm>
-          <a:prstGeom prst="rect">
-            <a:avLst/>
-          </a:prstGeom>
-          <a:noFill/>
-          <a:ln w="9525">
-            <a:noFill/>
-            <a:miter lim="800000"/>
-            <a:headEnd/>
-            <a:tailEnd/>
-          </a:ln>
-        </p:spPr>
-        <p:txBody>
-          <a:bodyPr wrap="square">
-            <a:spAutoFit/>
-          </a:bodyPr>
-          <a:lstStyle/>
-          <a:p>
-            <a:pPr marL="342900" marR="0" lvl="0" indent="-342900" algn="just" defTabSz="457200" rtl="0" eaLnBrk="1" fontAlgn="base" latinLnBrk="0" hangingPunct="1">
-              <a:lnSpc>
-                <a:spcPct val="100000"/>
-              </a:lnSpc>
-              <a:spcBef>
-                <a:spcPct val="0"/>
-              </a:spcBef>
-              <a:spcAft>
-                <a:spcPct val="0"/>
-              </a:spcAft>
-              <a:buClrTx/>
-              <a:buSzTx/>
-              <a:buFont typeface="Arial" panose="020B0604020202020204" pitchFamily="34" charset="0"/>
-              <a:buChar char="•"/>
-              <a:tabLst/>
-              <a:defRPr/>
-            </a:pPr>
-            <a:r>
-              <a:rPr lang="en-US" sz="2800" dirty="0">
-                <a:solidFill>
-                  <a:prstClr val="black"/>
-                </a:solidFill>
-                <a:latin typeface="Arial" pitchFamily="34" charset="0"/>
-                <a:cs typeface="Arial" pitchFamily="34" charset="0"/>
-              </a:rPr>
-              <a:t>Analysis of the feasibility of the idea</a:t>
-            </a:r>
-            <a:endParaRPr kumimoji="0" lang="en-US" sz="2800" b="0" i="0" u="none" strike="noStrike" kern="1200" cap="none" spc="0" normalizeH="0" baseline="0" noProof="0" dirty="0">
-              <a:ln>
-                <a:noFill/>
-              </a:ln>
-              <a:solidFill>
-                <a:prstClr val="black"/>
-              </a:solidFill>
-              <a:effectLst/>
-              <a:uLnTx/>
-              <a:uFillTx/>
-              <a:latin typeface="Arial" pitchFamily="34" charset="0"/>
-              <a:ea typeface="ＭＳ Ｐゴシック" pitchFamily="1" charset="-128"/>
-              <a:cs typeface="Arial" pitchFamily="34" charset="0"/>
-            </a:endParaRPr>
-          </a:p>
-          <a:p>
-            <a:pPr marL="342900" marR="0" lvl="0" indent="-342900" algn="just" defTabSz="457200" rtl="0" eaLnBrk="1" fontAlgn="base" latinLnBrk="0" hangingPunct="1">
-              <a:lnSpc>
-                <a:spcPct val="100000"/>
-              </a:lnSpc>
-              <a:spcBef>
-                <a:spcPct val="0"/>
-              </a:spcBef>
-              <a:spcAft>
-                <a:spcPct val="0"/>
-              </a:spcAft>
-              <a:buClrTx/>
-              <a:buSzTx/>
-              <a:buFont typeface="Arial" panose="020B0604020202020204" pitchFamily="34" charset="0"/>
-              <a:buChar char="•"/>
-              <a:tabLst/>
-              <a:defRPr/>
-            </a:pPr>
-            <a:r>
-              <a:rPr lang="en-US" sz="2800" dirty="0">
-                <a:solidFill>
-                  <a:prstClr val="black"/>
-                </a:solidFill>
-                <a:latin typeface="Arial" pitchFamily="34" charset="0"/>
-                <a:cs typeface="Arial" pitchFamily="34" charset="0"/>
-              </a:rPr>
-              <a:t>Potential challenges and risks</a:t>
-            </a:r>
-          </a:p>
-          <a:p>
-            <a:pPr marL="342900" marR="0" lvl="0" indent="-342900" algn="just" defTabSz="457200" rtl="0" eaLnBrk="1" fontAlgn="base" latinLnBrk="0" hangingPunct="1">
-              <a:lnSpc>
-                <a:spcPct val="100000"/>
-              </a:lnSpc>
-              <a:spcBef>
-                <a:spcPct val="0"/>
-              </a:spcBef>
-              <a:spcAft>
-                <a:spcPct val="0"/>
-              </a:spcAft>
-              <a:buClrTx/>
-              <a:buSzTx/>
-              <a:buFont typeface="Arial" panose="020B0604020202020204" pitchFamily="34" charset="0"/>
-              <a:buChar char="•"/>
-              <a:tabLst/>
-              <a:defRPr/>
-            </a:pPr>
-            <a:r>
-              <a:rPr kumimoji="0" lang="en-US" sz="2800" b="0" i="0" u="none" strike="noStrike" kern="1200" cap="none" spc="0" normalizeH="0" baseline="0" noProof="0" dirty="0">
-                <a:ln>
-                  <a:noFill/>
-                </a:ln>
-                <a:solidFill>
-                  <a:prstClr val="black"/>
-                </a:solidFill>
-                <a:effectLst/>
-                <a:uLnTx/>
-                <a:uFillTx/>
-                <a:latin typeface="Arial" pitchFamily="34" charset="0"/>
-                <a:ea typeface="ＭＳ Ｐゴシック" pitchFamily="1" charset="-128"/>
-                <a:cs typeface="Arial" pitchFamily="34" charset="0"/>
-              </a:rPr>
-              <a:t>Strategies</a:t>
-            </a:r>
-            <a:r>
-              <a:rPr kumimoji="0" lang="en-US" sz="2800" b="0" i="0" u="none" strike="noStrike" kern="1200" cap="none" spc="0" normalizeH="0" noProof="0" dirty="0">
-                <a:ln>
-                  <a:noFill/>
-                </a:ln>
-                <a:solidFill>
-                  <a:prstClr val="black"/>
-                </a:solidFill>
-                <a:effectLst/>
-                <a:uLnTx/>
-                <a:uFillTx/>
-                <a:latin typeface="Arial" pitchFamily="34" charset="0"/>
-                <a:ea typeface="ＭＳ Ｐゴシック" pitchFamily="1" charset="-128"/>
-                <a:cs typeface="Arial" pitchFamily="34" charset="0"/>
-              </a:rPr>
-              <a:t> for overcoming these challenges</a:t>
-            </a:r>
-            <a:endParaRPr kumimoji="0" lang="en-US" sz="2800" b="0" i="0" u="none" strike="noStrike" kern="1200" cap="none" spc="0" normalizeH="0" baseline="0" noProof="0" dirty="0">
-              <a:ln>
-                <a:noFill/>
-              </a:ln>
-              <a:solidFill>
-                <a:prstClr val="black"/>
-              </a:solidFill>
-              <a:effectLst/>
-              <a:uLnTx/>
-              <a:uFillTx/>
-              <a:latin typeface="Arial" pitchFamily="34" charset="0"/>
-              <a:ea typeface="ＭＳ Ｐゴシック" pitchFamily="1" charset="-128"/>
-              <a:cs typeface="Arial" pitchFamily="34" charset="0"/>
-            </a:endParaRPr>
-          </a:p>
-        </p:txBody>
-      </p:sp>
-      <p:sp>
-        <p:nvSpPr>
-          <p:cNvPr id="6" name="Slide Number Placeholder 5"/>
+              <a:t>ARTIFACTS</a:t>
+            </a:r>
+          </a:p>
+        </p:txBody>
+      </p:sp>
+      <p:sp>
+        <p:nvSpPr>
+          <p:cNvPr id="6" name="Slide Number Placeholder 5">
+            <a:extLst>
+              <a:ext uri="{FF2B5EF4-FFF2-40B4-BE49-F238E27FC236}">
+                <a16:creationId xmlns:a16="http://schemas.microsoft.com/office/drawing/2014/main" id="{84B14AAA-63FC-5F17-FE74-5405495A1CD3}"/>
+              </a:ext>
+            </a:extLst>
+          </p:cNvPr>
           <p:cNvSpPr>
             <a:spLocks noGrp="1"/>
           </p:cNvSpPr>
@@ -6760,7 +6731,13 @@
       </p:sp>
       <p:sp>
         <p:nvSpPr>
-          <p:cNvPr id="7" name="Footer Placeholder 6"/>
+          <p:cNvPr id="7" name="Footer Placeholder 6">
+            <a:extLst>
+              <a:ext uri="{FF2B5EF4-FFF2-40B4-BE49-F238E27FC236}">
+                <a16:creationId xmlns:a16="http://schemas.microsoft.com/office/drawing/2014/main" id="{34C6332B-BBD9-799D-50C5-6A19BC85E43E}"/>
+              </a:ext>
+            </a:extLst>
+          </p:cNvPr>
           <p:cNvSpPr>
             <a:spLocks noGrp="1"/>
           </p:cNvSpPr>
@@ -6829,10 +6806,100 @@
           </a:p>
         </p:txBody>
       </p:sp>
+      <p:pic>
+        <p:nvPicPr>
+          <p:cNvPr id="21" name="Picture 20">
+            <a:extLst>
+              <a:ext uri="{FF2B5EF4-FFF2-40B4-BE49-F238E27FC236}">
+                <a16:creationId xmlns:a16="http://schemas.microsoft.com/office/drawing/2014/main" id="{95E0F20C-B270-4D4F-6FCD-5170FB9C7BDB}"/>
+              </a:ext>
+            </a:extLst>
+          </p:cNvPr>
+          <p:cNvPicPr>
+            <a:picLocks noChangeAspect="1"/>
+          </p:cNvPicPr>
+          <p:nvPr/>
+        </p:nvPicPr>
+        <p:blipFill>
+          <a:blip r:embed="rId4"/>
+          <a:stretch>
+            <a:fillRect/>
+          </a:stretch>
+        </p:blipFill>
+        <p:spPr>
+          <a:xfrm>
+            <a:off x="3762800" y="3482364"/>
+            <a:ext cx="4003250" cy="3345452"/>
+          </a:xfrm>
+          <a:prstGeom prst="rect">
+            <a:avLst/>
+          </a:prstGeom>
+        </p:spPr>
+      </p:pic>
+      <p:pic>
+        <p:nvPicPr>
+          <p:cNvPr id="23" name="Picture 22">
+            <a:extLst>
+              <a:ext uri="{FF2B5EF4-FFF2-40B4-BE49-F238E27FC236}">
+                <a16:creationId xmlns:a16="http://schemas.microsoft.com/office/drawing/2014/main" id="{77488F1D-F26D-2C3F-2335-FE303DFEE7B6}"/>
+              </a:ext>
+            </a:extLst>
+          </p:cNvPr>
+          <p:cNvPicPr>
+            <a:picLocks noChangeAspect="1"/>
+          </p:cNvPicPr>
+          <p:nvPr/>
+        </p:nvPicPr>
+        <p:blipFill>
+          <a:blip r:embed="rId5"/>
+          <a:stretch>
+            <a:fillRect/>
+          </a:stretch>
+        </p:blipFill>
+        <p:spPr>
+          <a:xfrm>
+            <a:off x="7766050" y="3482365"/>
+            <a:ext cx="4425950" cy="3375636"/>
+          </a:xfrm>
+          <a:prstGeom prst="rect">
+            <a:avLst/>
+          </a:prstGeom>
+        </p:spPr>
+      </p:pic>
+      <p:pic>
+        <p:nvPicPr>
+          <p:cNvPr id="3" name="Picture 2">
+            <a:extLst>
+              <a:ext uri="{FF2B5EF4-FFF2-40B4-BE49-F238E27FC236}">
+                <a16:creationId xmlns:a16="http://schemas.microsoft.com/office/drawing/2014/main" id="{1C9BCE36-46F8-90C8-52F2-C354FF023FD7}"/>
+              </a:ext>
+            </a:extLst>
+          </p:cNvPr>
+          <p:cNvPicPr>
+            <a:picLocks noChangeAspect="1"/>
+          </p:cNvPicPr>
+          <p:nvPr/>
+        </p:nvPicPr>
+        <p:blipFill>
+          <a:blip r:embed="rId6"/>
+          <a:stretch>
+            <a:fillRect/>
+          </a:stretch>
+        </p:blipFill>
+        <p:spPr>
+          <a:xfrm>
+            <a:off x="0" y="3482364"/>
+            <a:ext cx="3762800" cy="3345452"/>
+          </a:xfrm>
+          <a:prstGeom prst="rect">
+            <a:avLst/>
+          </a:prstGeom>
+        </p:spPr>
+      </p:pic>
     </p:spTree>
     <p:extLst>
       <p:ext uri="{BB962C8B-B14F-4D97-AF65-F5344CB8AC3E}">
-        <p14:creationId xmlns:p14="http://schemas.microsoft.com/office/powerpoint/2010/main" val="3753387913"/>
+        <p14:creationId xmlns:p14="http://schemas.microsoft.com/office/powerpoint/2010/main" val="973447886"/>
       </p:ext>
     </p:extLst>
   </p:cSld>
@@ -6847,13 +6914,7 @@
   <p:cSld>
     <p:spTree>
       <p:nvGrpSpPr>
-        <p:cNvPr id="1" name="">
-          <a:extLst>
-            <a:ext uri="{FF2B5EF4-FFF2-40B4-BE49-F238E27FC236}">
-              <a16:creationId xmlns:a16="http://schemas.microsoft.com/office/drawing/2014/main" id="{48B09052-50AE-B3C2-6A1C-5CFF37D94A7E}"/>
-            </a:ext>
-          </a:extLst>
-        </p:cNvPr>
+        <p:cNvPr id="1" name=""/>
         <p:cNvGrpSpPr/>
         <p:nvPr/>
       </p:nvGrpSpPr>
@@ -6867,13 +6928,7 @@
       </p:grpSpPr>
       <p:sp>
         <p:nvSpPr>
-          <p:cNvPr id="17409" name="Title 1">
-            <a:extLst>
-              <a:ext uri="{FF2B5EF4-FFF2-40B4-BE49-F238E27FC236}">
-                <a16:creationId xmlns:a16="http://schemas.microsoft.com/office/drawing/2014/main" id="{5E03BF1A-7989-5C44-934B-D93E149184A6}"/>
-              </a:ext>
-            </a:extLst>
-          </p:cNvPr>
+          <p:cNvPr id="17409" name="Title 1"/>
           <p:cNvSpPr>
             <a:spLocks noGrp="1"/>
           </p:cNvSpPr>
@@ -6893,187 +6948,14 @@
                 <a:ea typeface="ＭＳ Ｐゴシック" pitchFamily="1" charset="-128"/>
                 <a:cs typeface="Times New Roman" panose="02020603050405020304" pitchFamily="18" charset="0"/>
               </a:rPr>
-              <a:t>ARTIFACTS</a:t>
-            </a:r>
-          </a:p>
-        </p:txBody>
-      </p:sp>
-      <p:sp>
-        <p:nvSpPr>
-          <p:cNvPr id="17410" name="TextBox 8">
-            <a:extLst>
-              <a:ext uri="{FF2B5EF4-FFF2-40B4-BE49-F238E27FC236}">
-                <a16:creationId xmlns:a16="http://schemas.microsoft.com/office/drawing/2014/main" id="{DD0C6F84-D6ED-416D-7179-055149D83FA6}"/>
-              </a:ext>
-            </a:extLst>
-          </p:cNvPr>
-          <p:cNvSpPr txBox="1">
-            <a:spLocks noChangeArrowheads="1"/>
-          </p:cNvSpPr>
-          <p:nvPr/>
-        </p:nvSpPr>
-        <p:spPr bwMode="auto">
-          <a:xfrm>
-            <a:off x="609600" y="2533653"/>
-            <a:ext cx="9385300" cy="2246769"/>
-          </a:xfrm>
-          <a:prstGeom prst="rect">
-            <a:avLst/>
-          </a:prstGeom>
-          <a:noFill/>
-          <a:ln w="9525">
-            <a:noFill/>
-            <a:miter lim="800000"/>
-            <a:headEnd/>
-            <a:tailEnd/>
-          </a:ln>
-        </p:spPr>
-        <p:txBody>
-          <a:bodyPr wrap="square">
-            <a:spAutoFit/>
-          </a:bodyPr>
-          <a:lstStyle/>
-          <a:p>
-            <a:pPr marL="342900" marR="0" lvl="0" indent="-342900" algn="just" defTabSz="457200" rtl="0" eaLnBrk="1" fontAlgn="base" latinLnBrk="0" hangingPunct="1">
-              <a:lnSpc>
-                <a:spcPct val="100000"/>
-              </a:lnSpc>
-              <a:spcBef>
-                <a:spcPct val="0"/>
-              </a:spcBef>
-              <a:spcAft>
-                <a:spcPct val="0"/>
-              </a:spcAft>
-              <a:buClrTx/>
-              <a:buSzTx/>
-              <a:buFont typeface="Arial" panose="020B0604020202020204" pitchFamily="34" charset="0"/>
-              <a:buChar char="•"/>
-              <a:tabLst/>
-              <a:defRPr/>
-            </a:pPr>
-            <a:r>
-              <a:rPr lang="en-US" sz="2800" dirty="0">
-                <a:solidFill>
-                  <a:prstClr val="black"/>
-                </a:solidFill>
-                <a:latin typeface="Arial" pitchFamily="34" charset="0"/>
-                <a:cs typeface="Arial" pitchFamily="34" charset="0"/>
-              </a:rPr>
-              <a:t>Relevant artifacts, such as :</a:t>
-            </a:r>
-          </a:p>
-          <a:p>
-            <a:pPr marL="800100" lvl="1" indent="-342900" algn="just">
-              <a:buFont typeface="Arial" panose="020B0604020202020204" pitchFamily="34" charset="0"/>
-              <a:buChar char="•"/>
-              <a:defRPr/>
-            </a:pPr>
-            <a:r>
-              <a:rPr lang="en-US" sz="2800" dirty="0">
-                <a:solidFill>
-                  <a:prstClr val="black"/>
-                </a:solidFill>
-                <a:latin typeface="Arial" pitchFamily="34" charset="0"/>
-                <a:cs typeface="Arial" pitchFamily="34" charset="0"/>
-              </a:rPr>
-              <a:t>Copy of the Code Embedded</a:t>
-            </a:r>
-          </a:p>
-          <a:p>
-            <a:pPr marL="800100" lvl="1" indent="-342900" algn="just">
-              <a:buFont typeface="Arial" panose="020B0604020202020204" pitchFamily="34" charset="0"/>
-              <a:buChar char="•"/>
-              <a:defRPr/>
-            </a:pPr>
-            <a:r>
-              <a:rPr kumimoji="0" lang="en-US" sz="2800" b="0" i="0" u="none" strike="noStrike" kern="1200" cap="none" spc="0" normalizeH="0" baseline="0" noProof="0" dirty="0">
-                <a:ln>
-                  <a:noFill/>
-                </a:ln>
-                <a:solidFill>
-                  <a:prstClr val="black"/>
-                </a:solidFill>
-                <a:effectLst/>
-                <a:uLnTx/>
-                <a:uFillTx/>
-                <a:latin typeface="Arial" pitchFamily="34" charset="0"/>
-                <a:ea typeface="ＭＳ Ｐゴシック" pitchFamily="1" charset="-128"/>
-                <a:cs typeface="Arial" pitchFamily="34" charset="0"/>
-              </a:rPr>
-              <a:t>Snaps of the </a:t>
-            </a:r>
-            <a:r>
-              <a:rPr lang="en-US" sz="2800" dirty="0">
-                <a:solidFill>
-                  <a:prstClr val="black"/>
-                </a:solidFill>
-                <a:latin typeface="Arial" pitchFamily="34" charset="0"/>
-                <a:cs typeface="Arial" pitchFamily="34" charset="0"/>
-              </a:rPr>
-              <a:t>solution proposal</a:t>
-            </a:r>
-          </a:p>
-          <a:p>
-            <a:pPr marL="800100" lvl="1" indent="-342900" algn="just">
-              <a:buFont typeface="Arial" panose="020B0604020202020204" pitchFamily="34" charset="0"/>
-              <a:buChar char="•"/>
-              <a:defRPr/>
-            </a:pPr>
-            <a:r>
-              <a:rPr lang="en-US" sz="2800" dirty="0">
-                <a:solidFill>
-                  <a:prstClr val="black"/>
-                </a:solidFill>
-                <a:latin typeface="Arial" pitchFamily="34" charset="0"/>
-                <a:cs typeface="Arial" pitchFamily="34" charset="0"/>
-              </a:rPr>
-              <a:t>Dashboard snaps</a:t>
-            </a:r>
-          </a:p>
-          <a:p>
-            <a:pPr marL="342900" marR="0" lvl="0" indent="-342900" algn="just" defTabSz="457200" rtl="0" eaLnBrk="1" fontAlgn="base" latinLnBrk="0" hangingPunct="1">
-              <a:lnSpc>
-                <a:spcPct val="100000"/>
-              </a:lnSpc>
-              <a:spcBef>
-                <a:spcPct val="0"/>
-              </a:spcBef>
-              <a:spcAft>
-                <a:spcPct val="0"/>
-              </a:spcAft>
-              <a:buClrTx/>
-              <a:buSzTx/>
-              <a:buFont typeface="Arial" panose="020B0604020202020204" pitchFamily="34" charset="0"/>
-              <a:buChar char="•"/>
-              <a:tabLst/>
-              <a:defRPr/>
-            </a:pPr>
-            <a:endParaRPr kumimoji="0" lang="en-US" sz="2800" b="0" i="0" u="none" strike="noStrike" kern="1200" cap="none" spc="0" normalizeH="0" baseline="0" noProof="0" dirty="0">
-              <a:ln>
-                <a:noFill/>
-              </a:ln>
-              <a:solidFill>
-                <a:prstClr val="black"/>
-              </a:solidFill>
-              <a:effectLst/>
-              <a:uLnTx/>
-              <a:uFillTx/>
-              <a:latin typeface="Arial" pitchFamily="34" charset="0"/>
-              <a:ea typeface="ＭＳ Ｐゴシック" pitchFamily="1" charset="-128"/>
-              <a:cs typeface="Arial" pitchFamily="34" charset="0"/>
-            </a:endParaRPr>
-          </a:p>
-        </p:txBody>
-      </p:sp>
-      <p:sp>
-        <p:nvSpPr>
-          <p:cNvPr id="6" name="Slide Number Placeholder 5">
-            <a:extLst>
-              <a:ext uri="{FF2B5EF4-FFF2-40B4-BE49-F238E27FC236}">
-                <a16:creationId xmlns:a16="http://schemas.microsoft.com/office/drawing/2014/main" id="{84B14AAA-63FC-5F17-FE74-5405495A1CD3}"/>
-              </a:ext>
-            </a:extLst>
-          </p:cNvPr>
+              <a:t>RESEARCH  AND REFERENCES</a:t>
+            </a:r>
+          </a:p>
+        </p:txBody>
+      </p:sp>
+      <p:sp>
+        <p:nvSpPr>
+          <p:cNvPr id="6" name="Slide Number Placeholder 5"/>
           <p:cNvSpPr>
             <a:spLocks noGrp="1"/>
           </p:cNvSpPr>
@@ -7156,13 +7038,7 @@
       </p:sp>
       <p:sp>
         <p:nvSpPr>
-          <p:cNvPr id="7" name="Footer Placeholder 6">
-            <a:extLst>
-              <a:ext uri="{FF2B5EF4-FFF2-40B4-BE49-F238E27FC236}">
-                <a16:creationId xmlns:a16="http://schemas.microsoft.com/office/drawing/2014/main" id="{34C6332B-BBD9-799D-50C5-6A19BC85E43E}"/>
-              </a:ext>
-            </a:extLst>
-          </p:cNvPr>
+          <p:cNvPr id="7" name="Footer Placeholder 6"/>
           <p:cNvSpPr>
             <a:spLocks noGrp="1"/>
           </p:cNvSpPr>
@@ -7231,86 +7107,372 @@
           </a:p>
         </p:txBody>
       </p:sp>
-    </p:spTree>
-    <p:extLst>
-      <p:ext uri="{BB962C8B-B14F-4D97-AF65-F5344CB8AC3E}">
-        <p14:creationId xmlns:p14="http://schemas.microsoft.com/office/powerpoint/2010/main" val="973447886"/>
-      </p:ext>
-    </p:extLst>
-  </p:cSld>
-  <p:clrMapOvr>
-    <a:masterClrMapping/>
-  </p:clrMapOvr>
-</p:sld>
-</file>
-
-<file path=ppt/slides/slide7.xml><?xml version="1.0" encoding="utf-8"?>
-<p:sld xmlns:a="http://schemas.openxmlformats.org/drawingml/2006/main" xmlns:r="http://schemas.openxmlformats.org/officeDocument/2006/relationships" xmlns:p="http://schemas.openxmlformats.org/presentationml/2006/main">
-  <p:cSld>
-    <p:spTree>
-      <p:nvGrpSpPr>
-        <p:cNvPr id="1" name=""/>
-        <p:cNvGrpSpPr/>
-        <p:nvPr/>
-      </p:nvGrpSpPr>
-      <p:grpSpPr>
-        <a:xfrm>
-          <a:off x="0" y="0"/>
-          <a:ext cx="0" cy="0"/>
-          <a:chOff x="0" y="0"/>
-          <a:chExt cx="0" cy="0"/>
-        </a:xfrm>
-      </p:grpSpPr>
-      <p:sp>
-        <p:nvSpPr>
-          <p:cNvPr id="17409" name="Title 1"/>
-          <p:cNvSpPr>
-            <a:spLocks noGrp="1"/>
-          </p:cNvSpPr>
-          <p:nvPr>
-            <p:ph type="title"/>
-          </p:nvPr>
-        </p:nvSpPr>
-        <p:spPr/>
-        <p:txBody>
-          <a:bodyPr/>
-          <a:lstStyle/>
-          <a:p>
-            <a:pPr eaLnBrk="1" hangingPunct="1"/>
-            <a:r>
-              <a:rPr lang="en-US" sz="3600" b="1" dirty="0">
-                <a:latin typeface="Times New Roman" panose="02020603050405020304" pitchFamily="18" charset="0"/>
-                <a:ea typeface="ＭＳ Ｐゴシック" pitchFamily="1" charset="-128"/>
-                <a:cs typeface="Times New Roman" panose="02020603050405020304" pitchFamily="18" charset="0"/>
-              </a:rPr>
-              <a:t>RESEARCH  AND REFERENCES</a:t>
-            </a:r>
-          </a:p>
-        </p:txBody>
-      </p:sp>
-      <p:sp>
-        <p:nvSpPr>
-          <p:cNvPr id="17410" name="TextBox 8"/>
-          <p:cNvSpPr txBox="1">
-            <a:spLocks noChangeArrowheads="1"/>
-          </p:cNvSpPr>
+      <p:graphicFrame>
+        <p:nvGraphicFramePr>
+          <p:cNvPr id="2" name="Table 1">
+            <a:extLst>
+              <a:ext uri="{FF2B5EF4-FFF2-40B4-BE49-F238E27FC236}">
+                <a16:creationId xmlns:a16="http://schemas.microsoft.com/office/drawing/2014/main" id="{DAC5FC98-4581-C081-92B9-D4487747CD05}"/>
+              </a:ext>
+            </a:extLst>
+          </p:cNvPr>
+          <p:cNvGraphicFramePr>
+            <a:graphicFrameLocks noGrp="1"/>
+          </p:cNvGraphicFramePr>
+          <p:nvPr>
+            <p:extLst>
+              <p:ext uri="{D42A27DB-BD31-4B8C-83A1-F6EECF244321}">
+                <p14:modId xmlns:p14="http://schemas.microsoft.com/office/powerpoint/2010/main" val="1437019799"/>
+              </p:ext>
+            </p:extLst>
+          </p:nvPr>
+        </p:nvGraphicFramePr>
+        <p:xfrm>
+          <a:off x="609600" y="1095375"/>
+          <a:ext cx="6863114" cy="3108960"/>
+        </p:xfrm>
+        <a:graphic>
+          <a:graphicData uri="http://schemas.openxmlformats.org/drawingml/2006/table">
+            <a:tbl>
+              <a:tblPr>
+                <a:tableStyleId>{2D5ABB26-0587-4C30-8999-92F81FD0307C}</a:tableStyleId>
+              </a:tblPr>
+              <a:tblGrid>
+                <a:gridCol w="3431557">
+                  <a:extLst>
+                    <a:ext uri="{9D8B030D-6E8A-4147-A177-3AD203B41FA5}">
+                      <a16:colId xmlns:a16="http://schemas.microsoft.com/office/drawing/2014/main" val="293130365"/>
+                    </a:ext>
+                  </a:extLst>
+                </a:gridCol>
+                <a:gridCol w="3431557">
+                  <a:extLst>
+                    <a:ext uri="{9D8B030D-6E8A-4147-A177-3AD203B41FA5}">
+                      <a16:colId xmlns:a16="http://schemas.microsoft.com/office/drawing/2014/main" val="2946274100"/>
+                    </a:ext>
+                  </a:extLst>
+                </a:gridCol>
+              </a:tblGrid>
+              <a:tr h="343640">
+                <a:tc>
+                  <a:txBody>
+                    <a:bodyPr/>
+                    <a:lstStyle/>
+                    <a:p>
+                      <a:pPr>
+                        <a:buNone/>
+                      </a:pPr>
+                      <a:r>
+                        <a:rPr lang="en-IN" dirty="0"/>
+                        <a:t>Resource</a:t>
+                      </a:r>
+                    </a:p>
+                  </a:txBody>
+                  <a:tcPr anchor="ctr"/>
+                </a:tc>
+                <a:tc>
+                  <a:txBody>
+                    <a:bodyPr/>
+                    <a:lstStyle/>
+                    <a:p>
+                      <a:pPr>
+                        <a:buNone/>
+                      </a:pPr>
+                      <a:r>
+                        <a:rPr lang="en-IN"/>
+                        <a:t>Official Link</a:t>
+                      </a:r>
+                    </a:p>
+                  </a:txBody>
+                  <a:tcPr anchor="ctr"/>
+                </a:tc>
+                <a:extLst>
+                  <a:ext uri="{0D108BD9-81ED-4DB2-BD59-A6C34878D82A}">
+                    <a16:rowId xmlns:a16="http://schemas.microsoft.com/office/drawing/2014/main" val="2719784543"/>
+                  </a:ext>
+                </a:extLst>
+              </a:tr>
+              <a:tr h="343640">
+                <a:tc>
+                  <a:txBody>
+                    <a:bodyPr/>
+                    <a:lstStyle/>
+                    <a:p>
+                      <a:pPr>
+                        <a:buNone/>
+                      </a:pPr>
+                      <a:r>
+                        <a:rPr lang="en-IN" dirty="0" err="1"/>
+                        <a:t>EnergyPlus</a:t>
+                      </a:r>
+                      <a:r>
+                        <a:rPr lang="en-IN" dirty="0"/>
+                        <a:t> Documentation</a:t>
+                      </a:r>
+                    </a:p>
+                  </a:txBody>
+                  <a:tcPr anchor="ctr"/>
+                </a:tc>
+                <a:tc>
+                  <a:txBody>
+                    <a:bodyPr/>
+                    <a:lstStyle/>
+                    <a:p>
+                      <a:pPr>
+                        <a:buNone/>
+                      </a:pPr>
+                      <a:r>
+                        <a:rPr lang="en-IN">
+                          <a:hlinkClick r:id="rId3"/>
+                        </a:rPr>
+                        <a:t>https://energyplus.readthedocs.io</a:t>
+                      </a:r>
+                      <a:endParaRPr lang="en-IN"/>
+                    </a:p>
+                  </a:txBody>
+                  <a:tcPr anchor="ctr"/>
+                </a:tc>
+                <a:extLst>
+                  <a:ext uri="{0D108BD9-81ED-4DB2-BD59-A6C34878D82A}">
+                    <a16:rowId xmlns:a16="http://schemas.microsoft.com/office/drawing/2014/main" val="2952106476"/>
+                  </a:ext>
+                </a:extLst>
+              </a:tr>
+              <a:tr h="343640">
+                <a:tc>
+                  <a:txBody>
+                    <a:bodyPr/>
+                    <a:lstStyle/>
+                    <a:p>
+                      <a:pPr>
+                        <a:buNone/>
+                      </a:pPr>
+                      <a:r>
+                        <a:rPr lang="en-IN" dirty="0"/>
+                        <a:t>Honeywell Forge Documentation</a:t>
+                      </a:r>
+                    </a:p>
+                  </a:txBody>
+                  <a:tcPr anchor="ctr"/>
+                </a:tc>
+                <a:tc>
+                  <a:txBody>
+                    <a:bodyPr/>
+                    <a:lstStyle/>
+                    <a:p>
+                      <a:pPr>
+                        <a:buNone/>
+                      </a:pPr>
+                      <a:r>
+                        <a:rPr lang="en-IN">
+                          <a:hlinkClick r:id="rId4"/>
+                        </a:rPr>
+                        <a:t>Honeywell Forge Documentation</a:t>
+                      </a:r>
+                      <a:endParaRPr lang="en-IN"/>
+                    </a:p>
+                  </a:txBody>
+                  <a:tcPr anchor="ctr"/>
+                </a:tc>
+                <a:extLst>
+                  <a:ext uri="{0D108BD9-81ED-4DB2-BD59-A6C34878D82A}">
+                    <a16:rowId xmlns:a16="http://schemas.microsoft.com/office/drawing/2014/main" val="1451678672"/>
+                  </a:ext>
+                </a:extLst>
+              </a:tr>
+              <a:tr h="343640">
+                <a:tc>
+                  <a:txBody>
+                    <a:bodyPr/>
+                    <a:lstStyle/>
+                    <a:p>
+                      <a:pPr>
+                        <a:buNone/>
+                      </a:pPr>
+                      <a:r>
+                        <a:rPr lang="en-IN"/>
+                        <a:t>Ollama Documentation</a:t>
+                      </a:r>
+                    </a:p>
+                  </a:txBody>
+                  <a:tcPr anchor="ctr"/>
+                </a:tc>
+                <a:tc>
+                  <a:txBody>
+                    <a:bodyPr/>
+                    <a:lstStyle/>
+                    <a:p>
+                      <a:pPr>
+                        <a:buNone/>
+                      </a:pPr>
+                      <a:r>
+                        <a:rPr lang="en-IN">
+                          <a:hlinkClick r:id="rId5"/>
+                        </a:rPr>
+                        <a:t>https://github.com/ollama/ollama/tree/main/docs</a:t>
+                      </a:r>
+                      <a:endParaRPr lang="en-IN"/>
+                    </a:p>
+                  </a:txBody>
+                  <a:tcPr anchor="ctr"/>
+                </a:tc>
+                <a:extLst>
+                  <a:ext uri="{0D108BD9-81ED-4DB2-BD59-A6C34878D82A}">
+                    <a16:rowId xmlns:a16="http://schemas.microsoft.com/office/drawing/2014/main" val="3022191360"/>
+                  </a:ext>
+                </a:extLst>
+              </a:tr>
+              <a:tr h="343640">
+                <a:tc>
+                  <a:txBody>
+                    <a:bodyPr/>
+                    <a:lstStyle/>
+                    <a:p>
+                      <a:pPr>
+                        <a:buNone/>
+                      </a:pPr>
+                      <a:r>
+                        <a:rPr lang="en-IN"/>
+                        <a:t>Qwen 2.5 Technical Report</a:t>
+                      </a:r>
+                    </a:p>
+                  </a:txBody>
+                  <a:tcPr anchor="ctr"/>
+                </a:tc>
+                <a:tc>
+                  <a:txBody>
+                    <a:bodyPr/>
+                    <a:lstStyle/>
+                    <a:p>
+                      <a:pPr>
+                        <a:buNone/>
+                      </a:pPr>
+                      <a:r>
+                        <a:rPr lang="en-IN">
+                          <a:hlinkClick r:id="rId6"/>
+                        </a:rPr>
+                        <a:t>https://qwenlm.github.io/blog/qwen2.5/</a:t>
+                      </a:r>
+                      <a:endParaRPr lang="en-IN"/>
+                    </a:p>
+                  </a:txBody>
+                  <a:tcPr anchor="ctr"/>
+                </a:tc>
+                <a:extLst>
+                  <a:ext uri="{0D108BD9-81ED-4DB2-BD59-A6C34878D82A}">
+                    <a16:rowId xmlns:a16="http://schemas.microsoft.com/office/drawing/2014/main" val="2259178961"/>
+                  </a:ext>
+                </a:extLst>
+              </a:tr>
+              <a:tr h="343640">
+                <a:tc>
+                  <a:txBody>
+                    <a:bodyPr/>
+                    <a:lstStyle/>
+                    <a:p>
+                      <a:pPr>
+                        <a:buNone/>
+                      </a:pPr>
+                      <a:r>
+                        <a:rPr lang="en-IN"/>
+                        <a:t>Plotly Dash Documentation</a:t>
+                      </a:r>
+                    </a:p>
+                  </a:txBody>
+                  <a:tcPr anchor="ctr"/>
+                </a:tc>
+                <a:tc>
+                  <a:txBody>
+                    <a:bodyPr/>
+                    <a:lstStyle/>
+                    <a:p>
+                      <a:pPr>
+                        <a:buNone/>
+                      </a:pPr>
+                      <a:r>
+                        <a:rPr lang="en-IN">
+                          <a:hlinkClick r:id="rId7"/>
+                        </a:rPr>
+                        <a:t>https://dash.plotly.com/</a:t>
+                      </a:r>
+                      <a:endParaRPr lang="en-IN"/>
+                    </a:p>
+                  </a:txBody>
+                  <a:tcPr anchor="ctr"/>
+                </a:tc>
+                <a:extLst>
+                  <a:ext uri="{0D108BD9-81ED-4DB2-BD59-A6C34878D82A}">
+                    <a16:rowId xmlns:a16="http://schemas.microsoft.com/office/drawing/2014/main" val="1142678842"/>
+                  </a:ext>
+                </a:extLst>
+              </a:tr>
+              <a:tr h="343640">
+                <a:tc>
+                  <a:txBody>
+                    <a:bodyPr/>
+                    <a:lstStyle/>
+                    <a:p>
+                      <a:pPr>
+                        <a:buNone/>
+                      </a:pPr>
+                      <a:r>
+                        <a:rPr lang="en-IN"/>
+                        <a:t>Python Documentation</a:t>
+                      </a:r>
+                    </a:p>
+                  </a:txBody>
+                  <a:tcPr anchor="ctr"/>
+                </a:tc>
+                <a:tc>
+                  <a:txBody>
+                    <a:bodyPr/>
+                    <a:lstStyle/>
+                    <a:p>
+                      <a:pPr>
+                        <a:buNone/>
+                      </a:pPr>
+                      <a:r>
+                        <a:rPr lang="en-IN" dirty="0">
+                          <a:hlinkClick r:id="rId8"/>
+                        </a:rPr>
+                        <a:t>https://docs.python.org/3/</a:t>
+                      </a:r>
+                      <a:endParaRPr lang="en-IN" dirty="0"/>
+                    </a:p>
+                  </a:txBody>
+                  <a:tcPr anchor="ctr"/>
+                </a:tc>
+                <a:extLst>
+                  <a:ext uri="{0D108BD9-81ED-4DB2-BD59-A6C34878D82A}">
+                    <a16:rowId xmlns:a16="http://schemas.microsoft.com/office/drawing/2014/main" val="3045804161"/>
+                  </a:ext>
+                </a:extLst>
+              </a:tr>
+            </a:tbl>
+          </a:graphicData>
+        </a:graphic>
+      </p:graphicFrame>
+      <p:sp>
+        <p:nvSpPr>
+          <p:cNvPr id="4" name="TextBox 3">
+            <a:extLst>
+              <a:ext uri="{FF2B5EF4-FFF2-40B4-BE49-F238E27FC236}">
+                <a16:creationId xmlns:a16="http://schemas.microsoft.com/office/drawing/2014/main" id="{791CBBDF-D851-FCF0-F2BC-2F796E9BC0A9}"/>
+              </a:ext>
+            </a:extLst>
+          </p:cNvPr>
+          <p:cNvSpPr txBox="1"/>
           <p:nvPr/>
         </p:nvSpPr>
-        <p:spPr bwMode="auto">
+        <p:spPr>
           <a:xfrm>
-            <a:off x="609600" y="2795263"/>
-            <a:ext cx="9385300" cy="523220"/>
+            <a:off x="609599" y="4736300"/>
+            <a:ext cx="11582401" cy="923330"/>
           </a:xfrm>
           <a:prstGeom prst="rect">
             <a:avLst/>
           </a:prstGeom>
           <a:noFill/>
-          <a:ln w="9525">
-            <a:noFill/>
-            <a:miter lim="800000"/>
-            <a:headEnd/>
-            <a:tailEnd/>
-          </a:ln>
         </p:spPr>
         <p:txBody>
           <a:bodyPr wrap="square">
@@ -7318,201 +7480,37 @@
           </a:bodyPr>
           <a:lstStyle/>
           <a:p>
-            <a:pPr marL="342900" marR="0" lvl="0" indent="-342900" algn="just" defTabSz="457200" rtl="0" eaLnBrk="1" fontAlgn="base" latinLnBrk="0" hangingPunct="1">
-              <a:lnSpc>
-                <a:spcPct val="100000"/>
-              </a:lnSpc>
-              <a:spcBef>
-                <a:spcPct val="0"/>
-              </a:spcBef>
-              <a:spcAft>
-                <a:spcPct val="0"/>
-              </a:spcAft>
-              <a:buClrTx/>
-              <a:buSzTx/>
-              <a:buFont typeface="Arial" panose="020B0604020202020204" pitchFamily="34" charset="0"/>
-              <a:buChar char="•"/>
-              <a:tabLst/>
-              <a:defRPr/>
-            </a:pPr>
-            <a:r>
-              <a:rPr lang="en-US" sz="2800" noProof="0" dirty="0">
-                <a:solidFill>
-                  <a:prstClr val="black"/>
-                </a:solidFill>
-                <a:latin typeface="Arial" pitchFamily="34" charset="0"/>
-                <a:cs typeface="Arial" pitchFamily="34" charset="0"/>
+            <a:r>
+              <a:rPr lang="en-IN" dirty="0">
+                <a:hlinkClick r:id="rId9"/>
               </a:rPr>
-              <a:t>Details / Links of the reference and research work</a:t>
-            </a:r>
-            <a:endParaRPr kumimoji="0" lang="en-US" sz="2800" b="0" i="0" u="none" strike="noStrike" kern="1200" cap="none" spc="0" normalizeH="0" baseline="0" noProof="0" dirty="0">
-              <a:ln>
-                <a:noFill/>
-              </a:ln>
-              <a:solidFill>
-                <a:prstClr val="black"/>
-              </a:solidFill>
-              <a:effectLst/>
-              <a:uLnTx/>
-              <a:uFillTx/>
-              <a:latin typeface="Arial" pitchFamily="34" charset="0"/>
-              <a:ea typeface="ＭＳ Ｐゴシック" pitchFamily="1" charset="-128"/>
-              <a:cs typeface="Arial" pitchFamily="34" charset="0"/>
-            </a:endParaRPr>
-          </a:p>
-        </p:txBody>
-      </p:sp>
-      <p:sp>
-        <p:nvSpPr>
-          <p:cNvPr id="6" name="Slide Number Placeholder 5"/>
-          <p:cNvSpPr>
-            <a:spLocks noGrp="1"/>
-          </p:cNvSpPr>
-          <p:nvPr>
-            <p:ph type="sldNum" sz="quarter" idx="12"/>
-          </p:nvPr>
-        </p:nvSpPr>
-        <p:spPr/>
-        <p:txBody>
-          <a:bodyPr/>
-          <a:lstStyle/>
-          <a:p>
-            <a:pPr marL="0" marR="0" lvl="0" indent="0" algn="r" defTabSz="457200" rtl="0" eaLnBrk="1" fontAlgn="base" latinLnBrk="0" hangingPunct="1">
-              <a:lnSpc>
-                <a:spcPct val="100000"/>
-              </a:lnSpc>
-              <a:spcBef>
-                <a:spcPct val="0"/>
-              </a:spcBef>
-              <a:spcAft>
-                <a:spcPct val="0"/>
-              </a:spcAft>
-              <a:buClrTx/>
-              <a:buSzTx/>
-              <a:buFontTx/>
-              <a:buNone/>
-              <a:tabLst/>
-              <a:defRPr/>
-            </a:pPr>
-            <a:fld id="{677C3CE7-23F7-4828-823C-E0205DF2CF97}" type="slidenum">
-              <a:rPr kumimoji="0" lang="en-US" sz="1200" b="1" i="0" u="none" strike="noStrike" kern="1200" cap="none" spc="0" normalizeH="0" baseline="0" noProof="0">
-                <a:ln>
-                  <a:noFill/>
-                </a:ln>
-                <a:solidFill>
-                  <a:prstClr val="white"/>
-                </a:solidFill>
-                <a:effectLst/>
-                <a:uLnTx/>
-                <a:uFillTx/>
-                <a:latin typeface="TradeGothic" pitchFamily="1" charset="0"/>
-                <a:ea typeface="ＭＳ Ｐゴシック" pitchFamily="1" charset="-128"/>
-                <a:cs typeface="+mn-cs"/>
+              <a:t>BACnet International Documentation</a:t>
+            </a:r>
+            <a:endParaRPr lang="en-IN" dirty="0"/>
+          </a:p>
+          <a:p>
+            <a:r>
+              <a:rPr lang="en-IN" dirty="0" err="1">
+                <a:hlinkClick r:id="rId10"/>
               </a:rPr>
-              <a:pPr marL="0" marR="0" lvl="0" indent="0" algn="r" defTabSz="457200" rtl="0" eaLnBrk="1" fontAlgn="base" latinLnBrk="0" hangingPunct="1">
-                <a:lnSpc>
-                  <a:spcPct val="100000"/>
-                </a:lnSpc>
-                <a:spcBef>
-                  <a:spcPct val="0"/>
-                </a:spcBef>
-                <a:spcAft>
-                  <a:spcPct val="0"/>
-                </a:spcAft>
-                <a:buClrTx/>
-                <a:buSzTx/>
-                <a:buFontTx/>
-                <a:buNone/>
-                <a:tabLst/>
-                <a:defRPr/>
-              </a:pPr>
-              <a:t>7</a:t>
-            </a:fld>
-            <a:endParaRPr kumimoji="0" lang="en-US" sz="1200" b="1" i="0" u="none" strike="noStrike" kern="1200" cap="none" spc="0" normalizeH="0" baseline="0" noProof="0" dirty="0">
-              <a:ln>
-                <a:noFill/>
-              </a:ln>
-              <a:solidFill>
-                <a:prstClr val="white"/>
-              </a:solidFill>
-              <a:effectLst/>
-              <a:uLnTx/>
-              <a:uFillTx/>
-              <a:latin typeface="TradeGothic" pitchFamily="1" charset="0"/>
-              <a:ea typeface="ＭＳ Ｐゴシック" pitchFamily="1" charset="-128"/>
-              <a:cs typeface="+mn-cs"/>
-            </a:endParaRPr>
-          </a:p>
-        </p:txBody>
-      </p:sp>
-      <p:sp>
-        <p:nvSpPr>
-          <p:cNvPr id="7" name="Footer Placeholder 6"/>
-          <p:cNvSpPr>
-            <a:spLocks noGrp="1"/>
-          </p:cNvSpPr>
-          <p:nvPr>
-            <p:ph type="ftr" sz="quarter" idx="11"/>
-          </p:nvPr>
-        </p:nvSpPr>
-        <p:spPr>
-          <a:xfrm>
-            <a:off x="4648200" y="6356353"/>
-            <a:ext cx="3204000" cy="365125"/>
-          </a:xfrm>
-        </p:spPr>
-        <p:txBody>
-          <a:bodyPr/>
-          <a:lstStyle/>
-          <a:p>
-            <a:pPr marL="0" marR="0" lvl="0" indent="0" algn="ctr" defTabSz="457200" rtl="0" eaLnBrk="1" fontAlgn="auto" latinLnBrk="0" hangingPunct="1">
-              <a:lnSpc>
-                <a:spcPct val="100000"/>
-              </a:lnSpc>
-              <a:spcBef>
-                <a:spcPts val="0"/>
-              </a:spcBef>
-              <a:spcAft>
-                <a:spcPts val="0"/>
-              </a:spcAft>
-              <a:buClrTx/>
-              <a:buSzTx/>
-              <a:buFontTx/>
-              <a:buNone/>
-              <a:tabLst/>
-              <a:defRPr/>
-            </a:pPr>
-            <a:r>
-              <a:rPr kumimoji="0" lang="en-US" sz="1200" b="0" i="0" u="none" strike="noStrike" kern="1200" cap="none" spc="0" normalizeH="0" baseline="0" noProof="0">
-                <a:ln>
-                  <a:noFill/>
-                </a:ln>
-                <a:solidFill>
-                  <a:prstClr val="white"/>
-                </a:solidFill>
-                <a:effectLst/>
-                <a:uLnTx/>
-                <a:uFillTx/>
-                <a:latin typeface="TradeGothic"/>
-                <a:ea typeface="+mn-ea"/>
-                <a:cs typeface="+mn-cs"/>
+              <a:t>OpenADR</a:t>
+            </a:r>
+            <a:r>
+              <a:rPr lang="en-IN" dirty="0">
+                <a:hlinkClick r:id="rId10"/>
               </a:rPr>
-              <a:t>@SIH Idea submission- Template</a:t>
-            </a:r>
-            <a:endParaRPr kumimoji="0" lang="en-US" sz="1200" b="0" i="0" u="none" strike="noStrike" kern="1200" cap="none" spc="0" normalizeH="0" baseline="0" noProof="0" dirty="0">
-              <a:ln>
-                <a:noFill/>
-              </a:ln>
-              <a:solidFill>
-                <a:prstClr val="white"/>
-              </a:solidFill>
-              <a:effectLst/>
-              <a:uLnTx/>
-              <a:uFillTx/>
-              <a:latin typeface="TradeGothic"/>
-              <a:ea typeface="+mn-ea"/>
-              <a:cs typeface="+mn-cs"/>
-            </a:endParaRPr>
+              <a:t> Alliance Documentation</a:t>
+            </a:r>
+            <a:endParaRPr lang="en-IN" dirty="0"/>
+          </a:p>
+          <a:p>
+            <a:r>
+              <a:rPr lang="en-IN" dirty="0">
+                <a:hlinkClick r:id="rId11"/>
+              </a:rPr>
+              <a:t>Model Context Protocol (MCP) Documentation</a:t>
+            </a:r>
+            <a:endParaRPr lang="en-IN" dirty="0"/>
           </a:p>
         </p:txBody>
       </p:sp>

</xml_diff>